<commit_message>
Center BUSTM on spoken intent matching and original few-shot evaluation
</commit_message>
<xml_diff>
--- a/slides/datasets-in-10-minutes-bustm.pptx
+++ b/slides/datasets-in-10-minutes-bustm.pptx
@@ -29,7 +29,6 @@
     <p:sldId id="277" r:id="rId27"/>
     <p:sldId id="278" r:id="rId28"/>
     <p:sldId id="279" r:id="rId29"/>
-    <p:sldId id="280" r:id="rId30"/>
     <p:sldId id="283" r:id="rId33"/>
     <p:sldId id="284" r:id="rId34"/>
     <p:sldId id="285" r:id="rId35"/>
@@ -50,7 +49,6 @@
     <p:sldId id="305" r:id="rId55"/>
     <p:sldId id="306" r:id="rId56"/>
     <p:sldId id="307" r:id="rId57"/>
-    <p:sldId id="308" r:id="rId58"/>
     <p:sldId id="309" r:id="rId59"/>
   </p:sldIdLst>
   <p:sldSz cx="9144000" cy="5143500" type="screen16x9"/>
@@ -14899,7 +14897,7 @@
                 <a:ea typeface="Noto Sans CJK JP"/>
                 <a:cs typeface="Noto Sans"/>
               </a:rPr>
-              <a:t>CLEVAでの利用と公開範囲</a:t>
+              <a:t>公開配布と利用条件</a:t>
             </a:r>
           </a:p>
         </p:txBody>
@@ -14947,7 +14945,7 @@
                 <a:ea typeface="Noto Sans CJK JP"/>
                 <a:cs typeface="Noto Sans"/>
               </a:rPr>
-              <a:t>4. CLEVAでの利用と公開範囲</a:t>
+              <a:t>4. 公開配布と利用条件</a:t>
             </a:r>
           </a:p>
         </p:txBody>
@@ -14960,7 +14958,7 @@
 </p:sld>
 </file>
 
-<file path=ppt/slides/slide25.xml><?xml version="1.0" encoding="utf-8"?>
+<file path=ppt/slides/slide26.xml><?xml version="1.0" encoding="utf-8"?>
 <p:sld xmlns:a="http://schemas.openxmlformats.org/drawingml/2006/main" xmlns:p="http://schemas.openxmlformats.org/presentationml/2006/main" xmlns:r="http://schemas.openxmlformats.org/officeDocument/2006/relationships">
   <p:cSld>
     <p:spTree>
@@ -15013,7 +15011,7 @@
                 <a:ea typeface="Noto Sans CJK JP"/>
                 <a:cs typeface="Noto Sans"/>
               </a:rPr>
-              <a:t>CLEVAは、短い発話の言い換え判定へ採用した</a:t>
+              <a:t>公式配布から入手でき、利用条件の確認が必要</a:t>
             </a:r>
           </a:p>
         </p:txBody>
@@ -15042,91 +15040,61 @@
           <a:p>
             <a:pPr marL="457200" indent="-355600">
               <a:lnSpc>
-                <a:spcPts val="2379"/>
+                <a:spcPts val="2320"/>
               </a:lnSpc>
               <a:spcAft>
                 <a:spcPts val="700"/>
               </a:spcAft>
-              <a:buSzPct val="66500"/>
+              <a:buSzPct val="68205"/>
               <a:buFont typeface="Noto Sans CJK JP"/>
               <a:buChar char="●"/>
-              <a:defRPr sz="2000" b="0">
-                <a:solidFill>
-                  <a:srgbClr val="303437"/>
-                </a:solidFill>
-                <a:latin typeface="Noto Sans"/>
-              </a:defRPr>
-            </a:pPr>
-            <a:r>
-              <a:rPr sz="2000" b="0" lang="ja-JP" altLang="en-US">
-                <a:solidFill>
-                  <a:srgbClr val="303437"/>
-                </a:solidFill>
-                <a:latin typeface="Noto Sans"/>
-                <a:ea typeface="Noto Sans CJK JP"/>
-                <a:cs typeface="Noto Sans"/>
-              </a:rPr>
-              <a:t>2023年のCLEVAは、CLUEとFewCLUEの発話対を二択形式に直し、同じことを述べているかを正解率で評価する。短い発話の課題にBUSTMを用いる。</a:t>
+              <a:defRPr sz="1950" b="0">
+                <a:solidFill>
+                  <a:srgbClr val="303437"/>
+                </a:solidFill>
+                <a:latin typeface="Noto Sans"/>
+              </a:defRPr>
+            </a:pPr>
+            <a:r>
+              <a:rPr sz="1950" b="0" lang="ja-JP" altLang="en-US">
+                <a:solidFill>
+                  <a:srgbClr val="303437"/>
+                </a:solidFill>
+                <a:latin typeface="Noto Sans"/>
+                <a:ea typeface="Noto Sans CJK JP"/>
+                <a:cs typeface="Noto Sans"/>
+              </a:rPr>
+              <a:t>OPPOの公式リポジトリは、FewCLUEでのBUSTM配布を案内し、2021年のデータセットの引用方法を示している。</a:t>
             </a:r>
           </a:p>
           <a:p>
             <a:pPr marL="457200" indent="-355600">
               <a:lnSpc>
-                <a:spcPts val="2379"/>
-              </a:lnSpc>
-              <a:spcAft>
-                <a:spcPts val="0"/>
-              </a:spcAft>
-              <a:buSzPct val="66500"/>
+                <a:spcPts val="2320"/>
+              </a:lnSpc>
+              <a:spcAft>
+                <a:spcPts val="0"/>
+              </a:spcAft>
+              <a:buSzPct val="68205"/>
               <a:buFont typeface="Noto Sans CJK JP"/>
               <a:buChar char="●"/>
-              <a:defRPr sz="2000" b="0">
-                <a:solidFill>
-                  <a:srgbClr val="303437"/>
-                </a:solidFill>
-                <a:latin typeface="Noto Sans"/>
-              </a:defRPr>
-            </a:pPr>
-            <a:r>
-              <a:rPr sz="2000" b="0" lang="ja-JP" altLang="en-US">
-                <a:solidFill>
-                  <a:srgbClr val="303437"/>
-                </a:solidFill>
-                <a:latin typeface="Noto Sans"/>
-                <a:ea typeface="Noto Sans CJK JP"/>
-                <a:cs typeface="Noto Sans"/>
-              </a:rPr>
-              <a:t>実例1の「怒りっぽいか」を尋ねる二つの発話は、CLEVA論文にも掲載されている。HELMにも同課題の評価実装が公開されている。</a:t>
-            </a:r>
-          </a:p>
-          <a:p>
-            <a:pPr marL="457200" indent="-355600">
-              <a:lnSpc>
-                <a:spcPts val="2379"/>
-              </a:lnSpc>
-              <a:spcAft>
-                <a:spcPts val="0"/>
-              </a:spcAft>
-              <a:buSzPct val="66500"/>
-              <a:buFont typeface="Noto Sans CJK JP"/>
-              <a:buChar char="●"/>
-              <a:defRPr sz="2000" b="0">
-                <a:solidFill>
-                  <a:srgbClr val="303437"/>
-                </a:solidFill>
-                <a:latin typeface="Noto Sans"/>
-              </a:defRPr>
-            </a:pPr>
-            <a:r>
-              <a:rPr sz="2000" b="0" lang="ja-JP" altLang="en-US">
-                <a:solidFill>
-                  <a:srgbClr val="303437"/>
-                </a:solidFill>
-                <a:latin typeface="Noto Sans"/>
-                <a:ea typeface="Noto Sans CJK JP"/>
-                <a:cs typeface="Noto Sans"/>
-              </a:rPr>
-              <a:t>CLEVAが評価に使ったBUSTMの問題数は、公開説明には記されていない。</a:t>
+              <a:defRPr sz="1950" b="0">
+                <a:solidFill>
+                  <a:srgbClr val="303437"/>
+                </a:solidFill>
+                <a:latin typeface="Noto Sans"/>
+              </a:defRPr>
+            </a:pPr>
+            <a:r>
+              <a:rPr sz="1950" b="0" lang="ja-JP" altLang="en-US">
+                <a:solidFill>
+                  <a:srgbClr val="303437"/>
+                </a:solidFill>
+                <a:latin typeface="Noto Sans"/>
+                <a:ea typeface="Noto Sans CJK JP"/>
+                <a:cs typeface="Noto Sans"/>
+              </a:rPr>
+              <a:t>OPPOのリポジトリにはライセンスが明示されていない。FewCLUEのREADMEでも、ライセンス欄は「追加中」とされている。再利用・再配布の条件は配布元へ確認する。</a:t>
             </a:r>
           </a:p>
         </p:txBody>
@@ -15174,7 +15142,310 @@
                 <a:ea typeface="Noto Sans CJK JP"/>
                 <a:cs typeface="Noto Sans"/>
               </a:rPr>
-              <a:t>4. CLEVAでの利用と公開範囲</a:t>
+              <a:t>4. 公開配布と利用条件</a:t>
+            </a:r>
+          </a:p>
+        </p:txBody>
+      </p:sp>
+      <p:sp>
+        <p:nvSpPr>
+          <p:cNvPr id="5" name="sources"/>
+          <p:cNvSpPr txBox="1"/>
+          <p:nvPr/>
+        </p:nvSpPr>
+        <p:spPr>
+          <a:xfrm>
+            <a:off x="502920" y="4517136"/>
+            <a:ext cx="8183879" cy="530352"/>
+          </a:xfrm>
+          <a:prstGeom prst="rect">
+            <a:avLst/>
+          </a:prstGeom>
+          <a:noFill/>
+        </p:spPr>
+        <p:txBody>
+          <a:bodyPr wrap="square" lIns="0" rIns="0" tIns="0" bIns="0">
+            <a:noAutofit/>
+          </a:bodyPr>
+          <a:lstStyle/>
+          <a:p>
+            <a:pPr algn="l">
+              <a:lnSpc>
+                <a:spcPts val="940"/>
+              </a:lnSpc>
+              <a:spcBef>
+                <a:spcPts val="0"/>
+              </a:spcBef>
+              <a:spcAft>
+                <a:spcPts val="140"/>
+              </a:spcAft>
+              <a:buNone/>
+              <a:defRPr sz="810" b="0">
+                <a:solidFill>
+                  <a:srgbClr val="303437"/>
+                </a:solidFill>
+                <a:latin typeface="Noto Sans"/>
+              </a:defRPr>
+            </a:pPr>
+            <a:r>
+              <a:rPr sz="810" b="0" lang="ja-JP" altLang="en-US">
+                <a:solidFill>
+                  <a:srgbClr val="626669"/>
+                </a:solidFill>
+                <a:latin typeface="Noto Sans"/>
+                <a:ea typeface="Noto Sans CJK JP"/>
+                <a:cs typeface="Noto Sans"/>
+              </a:rPr>
+              <a:t>[1] OPPO XiaoBu Conversational-AI Center (2021). BUSTM: OPPO XiaoBu Dialogue Short Text Matching Dataset.  </a:t>
+            </a:r>
+            <a:r>
+              <a:rPr sz="810" b="0" lang="ja-JP" altLang="en-US">
+                <a:solidFill>
+                  <a:srgbClr val="626669"/>
+                </a:solidFill>
+                <a:latin typeface="Noto Sans"/>
+                <a:ea typeface="Noto Sans CJK JP"/>
+                <a:cs typeface="Noto Sans"/>
+                <a:hlinkClick r:id="rId2"/>
+              </a:rPr>
+              <a:t>https://github.com/xiaobu-coai/BUSTM</a:t>
+            </a:r>
+          </a:p>
+          <a:p>
+            <a:pPr>
+              <a:lnSpc>
+                <a:spcPts val="940"/>
+              </a:lnSpc>
+              <a:spcAft>
+                <a:spcPts val="140"/>
+              </a:spcAft>
+              <a:buNone/>
+              <a:defRPr sz="810" b="0">
+                <a:solidFill>
+                  <a:srgbClr val="303437"/>
+                </a:solidFill>
+                <a:latin typeface="Noto Sans"/>
+              </a:defRPr>
+            </a:pPr>
+            <a:r>
+              <a:rPr sz="810" b="0" lang="ja-JP" altLang="en-US">
+                <a:solidFill>
+                  <a:srgbClr val="626669"/>
+                </a:solidFill>
+                <a:latin typeface="Noto Sans"/>
+                <a:ea typeface="Noto Sans CJK JP"/>
+                <a:cs typeface="Noto Sans"/>
+              </a:rPr>
+              <a:t>[2] CLUE team (2021). FewCLUE — README.  </a:t>
+            </a:r>
+            <a:r>
+              <a:rPr sz="810" b="0" lang="ja-JP" altLang="en-US">
+                <a:solidFill>
+                  <a:srgbClr val="626669"/>
+                </a:solidFill>
+                <a:latin typeface="Noto Sans"/>
+                <a:ea typeface="Noto Sans CJK JP"/>
+                <a:cs typeface="Noto Sans"/>
+                <a:hlinkClick r:id="rId4"/>
+              </a:rPr>
+              <a:t>https://github.com/CLUEbenchmark/FewCLUE/blob/main/README.md</a:t>
+            </a:r>
+          </a:p>
+        </p:txBody>
+      </p:sp>
+    </p:spTree>
+  </p:cSld>
+  <p:clrMapOvr>
+    <a:masterClrMapping/>
+  </p:clrMapOvr>
+</p:sld>
+</file>
+
+<file path=ppt/slides/slide27.xml><?xml version="1.0" encoding="utf-8"?>
+<p:sld xmlns:a="http://schemas.openxmlformats.org/drawingml/2006/main" xmlns:p="http://schemas.openxmlformats.org/presentationml/2006/main" xmlns:r="http://schemas.openxmlformats.org/officeDocument/2006/relationships">
+  <p:cSld>
+    <p:spTree>
+      <p:nvGrpSpPr>
+        <p:cNvPr id="1" name=""/>
+        <p:cNvGrpSpPr/>
+        <p:nvPr/>
+      </p:nvGrpSpPr>
+      <p:grpSpPr/>
+      <p:sp>
+        <p:nvSpPr>
+          <p:cNvPr id="2" name="Title 1"/>
+          <p:cNvSpPr>
+            <a:spLocks noGrp="1"/>
+          </p:cNvSpPr>
+          <p:nvPr>
+            <p:ph type="title"/>
+          </p:nvPr>
+        </p:nvSpPr>
+        <p:spPr>
+          <a:xfrm>
+            <a:off x="468172" y="650138"/>
+            <a:ext cx="8206740" cy="616305"/>
+          </a:xfrm>
+        </p:spPr>
+        <p:txBody>
+          <a:bodyPr wrap="square" lIns="0" rIns="0" tIns="0" bIns="0">
+            <a:noAutofit/>
+          </a:bodyPr>
+          <a:lstStyle/>
+          <a:p>
+            <a:pPr algn="l">
+              <a:lnSpc>
+                <a:spcPct val="110000"/>
+              </a:lnSpc>
+              <a:buNone/>
+              <a:defRPr sz="2800" b="0">
+                <a:solidFill>
+                  <a:srgbClr val="303437"/>
+                </a:solidFill>
+                <a:latin typeface="Noto Sans"/>
+              </a:defRPr>
+            </a:pPr>
+            <a:r>
+              <a:rPr sz="2800" b="1" lang="ja-JP" altLang="en-US">
+                <a:solidFill>
+                  <a:srgbClr val="303437"/>
+                </a:solidFill>
+                <a:latin typeface="Noto Sans"/>
+                <a:ea typeface="Noto Sans CJK JP"/>
+                <a:cs typeface="Noto Sans"/>
+              </a:rPr>
+              <a:t>まとめ：口語の意味を、少数例で照合する</a:t>
+            </a:r>
+          </a:p>
+        </p:txBody>
+      </p:sp>
+      <p:sp>
+        <p:nvSpPr>
+          <p:cNvPr id="3" name="Text Placeholder 2"/>
+          <p:cNvSpPr>
+            <a:spLocks noGrp="1"/>
+          </p:cNvSpPr>
+          <p:nvPr>
+            <p:ph type="body" idx="1"/>
+          </p:nvPr>
+        </p:nvSpPr>
+        <p:spPr>
+          <a:xfrm>
+            <a:off x="594360" y="1463040"/>
+            <a:ext cx="7955279" cy="3044952"/>
+          </a:xfrm>
+        </p:spPr>
+        <p:txBody>
+          <a:bodyPr wrap="square" tIns="91440" bIns="91440">
+            <a:noAutofit/>
+          </a:bodyPr>
+          <a:lstStyle/>
+          <a:p>
+            <a:pPr marL="457200" indent="-355600">
+              <a:lnSpc>
+                <a:spcPts val="2379"/>
+              </a:lnSpc>
+              <a:spcAft>
+                <a:spcPts val="700"/>
+              </a:spcAft>
+              <a:buSzPct val="66500"/>
+              <a:buFont typeface="Noto Sans CJK JP"/>
+              <a:buChar char="●"/>
+              <a:defRPr sz="2000" b="0">
+                <a:solidFill>
+                  <a:srgbClr val="303437"/>
+                </a:solidFill>
+                <a:latin typeface="Noto Sans"/>
+              </a:defRPr>
+            </a:pPr>
+            <a:r>
+              <a:rPr sz="2000" b="0" lang="ja-JP" altLang="en-US">
+                <a:solidFill>
+                  <a:srgbClr val="303437"/>
+                </a:solidFill>
+                <a:latin typeface="Noto Sans"/>
+                <a:ea typeface="Noto Sans CJK JP"/>
+                <a:cs typeface="Noto Sans"/>
+              </a:rPr>
+              <a:t>BUSTMは、小布助手に由来する短い中国語発話対の二値判定データ。言い換え、異なる操作、時点や欲求の違いを扱い、学習・開発を各32件から始める。</a:t>
+            </a:r>
+          </a:p>
+          <a:p>
+            <a:pPr marL="457200" indent="-355600">
+              <a:lnSpc>
+                <a:spcPts val="2379"/>
+              </a:lnSpc>
+              <a:spcAft>
+                <a:spcPts val="0"/>
+              </a:spcAft>
+              <a:buSzPct val="66500"/>
+              <a:buFont typeface="Noto Sans CJK JP"/>
+              <a:buChar char="●"/>
+              <a:defRPr sz="2000" b="0">
+                <a:solidFill>
+                  <a:srgbClr val="303437"/>
+                </a:solidFill>
+                <a:latin typeface="Noto Sans"/>
+              </a:defRPr>
+            </a:pPr>
+            <a:r>
+              <a:rPr sz="2000" b="0" lang="ja-JP" altLang="en-US">
+                <a:solidFill>
+                  <a:srgbClr val="303437"/>
+                </a:solidFill>
+                <a:latin typeface="Noto Sans"/>
+                <a:ea typeface="Noto Sans CJK JP"/>
+                <a:cs typeface="Noto Sans"/>
+              </a:rPr>
+              <a:t>FewCLUEの公開テストは1,772件。2021年のEFLの報告正解率は71.8%で、各100問を解いた人間評価は88%。</a:t>
+            </a:r>
+          </a:p>
+        </p:txBody>
+      </p:sp>
+      <p:sp>
+        <p:nvSpPr>
+          <p:cNvPr id="4" name="Title 3"/>
+          <p:cNvSpPr>
+            <a:spLocks noGrp="1"/>
+          </p:cNvSpPr>
+          <p:nvPr>
+            <p:ph type="title" idx="2"/>
+          </p:nvPr>
+        </p:nvSpPr>
+        <p:spPr>
+          <a:xfrm>
+            <a:off x="75895" y="0"/>
+            <a:ext cx="8115300" cy="480060"/>
+          </a:xfrm>
+        </p:spPr>
+        <p:txBody>
+          <a:bodyPr wrap="square" lIns="0" rIns="0" tIns="0" bIns="0" anchor="ctr">
+            <a:noAutofit/>
+          </a:bodyPr>
+          <a:lstStyle/>
+          <a:p>
+            <a:pPr algn="l">
+              <a:lnSpc>
+                <a:spcPct val="110000"/>
+              </a:lnSpc>
+              <a:buNone/>
+              <a:defRPr sz="1400" b="0">
+                <a:solidFill>
+                  <a:srgbClr val="303437"/>
+                </a:solidFill>
+                <a:latin typeface="Noto Sans"/>
+              </a:defRPr>
+            </a:pPr>
+            <a:r>
+              <a:rPr sz="1400" b="1" lang="ja-JP" altLang="en-US">
+                <a:solidFill>
+                  <a:srgbClr val="FFFEF8"/>
+                </a:solidFill>
+                <a:latin typeface="Noto Sans"/>
+                <a:ea typeface="Noto Sans CJK JP"/>
+                <a:cs typeface="Noto Sans"/>
+              </a:rPr>
+              <a:t>4. 公開配布と利用条件</a:t>
             </a:r>
           </a:p>
         </p:txBody>
@@ -15228,7 +15499,7 @@
                 <a:ea typeface="Noto Sans CJK JP"/>
                 <a:cs typeface="Noto Sans"/>
               </a:rPr>
-              <a:t>[1] Li et al. (2023). CLEVA: Chinese Language Models EVAluation Platform. EMNLP: System Demonstrations.</a:t>
+              <a:t>[1] Xu et al. (2021). FewCLUE: A Chinese Few-shot Learning Evaluation Benchmark. arXiv:2107.07498v2. </a:t>
             </a:r>
             <a:r>
               <a:rPr sz="810" b="0" lang="ja-JP" altLang="en-US">
@@ -15238,20 +15509,9 @@
                 <a:latin typeface="Noto Sans"/>
                 <a:ea typeface="Noto Sans CJK JP"/>
                 <a:cs typeface="Noto Sans"/>
-              </a:rPr>
-              <a:t>  </a:t>
-            </a:r>
-            <a:r>
-              <a:rPr sz="810" b="0" lang="ja-JP" altLang="en-US">
-                <a:solidFill>
-                  <a:srgbClr val="626669"/>
-                </a:solidFill>
-                <a:latin typeface="Noto Sans"/>
-                <a:ea typeface="Noto Sans CJK JP"/>
-                <a:cs typeface="Noto Sans"/>
                 <a:hlinkClick r:id="rId2"/>
               </a:rPr>
-              <a:t>https://aclanthology.org/2023.emnlp-demo.17/</a:t>
+              <a:t>https://arxiv.org/abs/2107.07498</a:t>
             </a:r>
           </a:p>
         </p:txBody>
@@ -15286,128 +15546,45 @@
         </p:nvSpPr>
         <p:spPr>
           <a:xfrm>
-            <a:off x="468172" y="650138"/>
-            <a:ext cx="8206740" cy="616305"/>
+            <a:off x="548640" y="2484835"/>
+            <a:ext cx="8046720" cy="585216"/>
           </a:xfrm>
         </p:spPr>
         <p:txBody>
-          <a:bodyPr wrap="square" lIns="0" rIns="0" tIns="0" bIns="0">
+          <a:bodyPr wrap="square" lIns="0" rIns="0" tIns="0" bIns="0" anchor="ctr">
             <a:noAutofit/>
           </a:bodyPr>
           <a:lstStyle/>
           <a:p>
-            <a:pPr algn="l">
+            <a:pPr algn="ctr">
               <a:lnSpc>
                 <a:spcPct val="110000"/>
               </a:lnSpc>
               <a:buNone/>
-              <a:defRPr sz="2800" b="0">
-                <a:solidFill>
-                  <a:srgbClr val="303437"/>
-                </a:solidFill>
-                <a:latin typeface="Noto Sans"/>
-              </a:defRPr>
-            </a:pPr>
-            <a:r>
-              <a:rPr sz="2800" b="1" lang="ja-JP" altLang="en-US">
-                <a:solidFill>
-                  <a:srgbClr val="303437"/>
-                </a:solidFill>
-                <a:latin typeface="Noto Sans"/>
-                <a:ea typeface="Noto Sans CJK JP"/>
-                <a:cs typeface="Noto Sans"/>
-              </a:rPr>
-              <a:t>公式配布から入手でき、利用条件の確認が必要</a:t>
+              <a:defRPr sz="3600" b="0">
+                <a:solidFill>
+                  <a:srgbClr val="303437"/>
+                </a:solidFill>
+                <a:latin typeface="Noto Sans"/>
+              </a:defRPr>
+            </a:pPr>
+            <a:r>
+              <a:rPr sz="3600" b="1" lang="ja-JP" altLang="en-US">
+                <a:solidFill>
+                  <a:srgbClr val="303437"/>
+                </a:solidFill>
+                <a:latin typeface="Noto Sans"/>
+                <a:ea typeface="Noto Sans CJK JP"/>
+                <a:cs typeface="Noto Sans"/>
+              </a:rPr>
+              <a:t>Appendix</a:t>
             </a:r>
           </a:p>
         </p:txBody>
       </p:sp>
       <p:sp>
         <p:nvSpPr>
-          <p:cNvPr id="3" name="Text Placeholder 2"/>
-          <p:cNvSpPr>
-            <a:spLocks noGrp="1"/>
-          </p:cNvSpPr>
-          <p:nvPr>
-            <p:ph type="body" idx="1"/>
-          </p:nvPr>
-        </p:nvSpPr>
-        <p:spPr>
-          <a:xfrm>
-            <a:off x="594360" y="1463040"/>
-            <a:ext cx="7955279" cy="3044952"/>
-          </a:xfrm>
-        </p:spPr>
-        <p:txBody>
-          <a:bodyPr wrap="square" tIns="91440" bIns="91440">
-            <a:noAutofit/>
-          </a:bodyPr>
-          <a:lstStyle/>
-          <a:p>
-            <a:pPr marL="457200" indent="-355600">
-              <a:lnSpc>
-                <a:spcPts val="2320"/>
-              </a:lnSpc>
-              <a:spcAft>
-                <a:spcPts val="700"/>
-              </a:spcAft>
-              <a:buSzPct val="68205"/>
-              <a:buFont typeface="Noto Sans CJK JP"/>
-              <a:buChar char="●"/>
-              <a:defRPr sz="1950" b="0">
-                <a:solidFill>
-                  <a:srgbClr val="303437"/>
-                </a:solidFill>
-                <a:latin typeface="Noto Sans"/>
-              </a:defRPr>
-            </a:pPr>
-            <a:r>
-              <a:rPr sz="1950" b="0" lang="ja-JP" altLang="en-US">
-                <a:solidFill>
-                  <a:srgbClr val="303437"/>
-                </a:solidFill>
-                <a:latin typeface="Noto Sans"/>
-                <a:ea typeface="Noto Sans CJK JP"/>
-                <a:cs typeface="Noto Sans"/>
-              </a:rPr>
-              <a:t>OPPOの公式リポジトリは、FewCLUEでのBUSTM配布を案内し、2021年のデータセットの引用方法を示している。</a:t>
-            </a:r>
-          </a:p>
-          <a:p>
-            <a:pPr marL="457200" indent="-355600">
-              <a:lnSpc>
-                <a:spcPts val="2320"/>
-              </a:lnSpc>
-              <a:spcAft>
-                <a:spcPts val="0"/>
-              </a:spcAft>
-              <a:buSzPct val="68205"/>
-              <a:buFont typeface="Noto Sans CJK JP"/>
-              <a:buChar char="●"/>
-              <a:defRPr sz="1950" b="0">
-                <a:solidFill>
-                  <a:srgbClr val="303437"/>
-                </a:solidFill>
-                <a:latin typeface="Noto Sans"/>
-              </a:defRPr>
-            </a:pPr>
-            <a:r>
-              <a:rPr sz="1950" b="0" lang="ja-JP" altLang="en-US">
-                <a:solidFill>
-                  <a:srgbClr val="303437"/>
-                </a:solidFill>
-                <a:latin typeface="Noto Sans"/>
-                <a:ea typeface="Noto Sans CJK JP"/>
-                <a:cs typeface="Noto Sans"/>
-              </a:rPr>
-              <a:t>OPPOのリポジトリにはライセンスが明示されていない。FewCLUEのREADMEでも、ライセンス欄は「追加中」とされている。再利用・再配布の条件は配布元へ確認する。</a:t>
-            </a:r>
-          </a:p>
-        </p:txBody>
-      </p:sp>
-      <p:sp>
-        <p:nvSpPr>
-          <p:cNvPr id="4" name="Title 3"/>
+          <p:cNvPr id="3" name="Title 2"/>
           <p:cNvSpPr>
             <a:spLocks noGrp="1"/>
           </p:cNvSpPr>
@@ -15448,113 +15625,7 @@
                 <a:ea typeface="Noto Sans CJK JP"/>
                 <a:cs typeface="Noto Sans"/>
               </a:rPr>
-              <a:t>4. CLEVAでの利用と公開範囲</a:t>
-            </a:r>
-          </a:p>
-        </p:txBody>
-      </p:sp>
-      <p:sp>
-        <p:nvSpPr>
-          <p:cNvPr id="5" name="sources"/>
-          <p:cNvSpPr txBox="1"/>
-          <p:nvPr/>
-        </p:nvSpPr>
-        <p:spPr>
-          <a:xfrm>
-            <a:off x="502920" y="4517136"/>
-            <a:ext cx="8183879" cy="530352"/>
-          </a:xfrm>
-          <a:prstGeom prst="rect">
-            <a:avLst/>
-          </a:prstGeom>
-          <a:noFill/>
-        </p:spPr>
-        <p:txBody>
-          <a:bodyPr wrap="square" lIns="0" rIns="0" tIns="0" bIns="0">
-            <a:noAutofit/>
-          </a:bodyPr>
-          <a:lstStyle/>
-          <a:p>
-            <a:pPr algn="l">
-              <a:lnSpc>
-                <a:spcPts val="940"/>
-              </a:lnSpc>
-              <a:spcBef>
-                <a:spcPts val="0"/>
-              </a:spcBef>
-              <a:spcAft>
-                <a:spcPts val="140"/>
-              </a:spcAft>
-              <a:buNone/>
-              <a:defRPr sz="810" b="0">
-                <a:solidFill>
-                  <a:srgbClr val="303437"/>
-                </a:solidFill>
-                <a:latin typeface="Noto Sans"/>
-              </a:defRPr>
-            </a:pPr>
-            <a:r>
-              <a:rPr sz="810" b="0" lang="ja-JP" altLang="en-US">
-                <a:solidFill>
-                  <a:srgbClr val="626669"/>
-                </a:solidFill>
-                <a:latin typeface="Noto Sans"/>
-                <a:ea typeface="Noto Sans CJK JP"/>
-                <a:cs typeface="Noto Sans"/>
-              </a:rPr>
-              <a:t>[1] OPPO XiaoBu Conversational-AI Center (2021). BUSTM: OPPO XiaoBu Dialogue Short Text Matching Dataset.  </a:t>
-            </a:r>
-            <a:r>
-              <a:rPr sz="810" b="0" lang="ja-JP" altLang="en-US">
-                <a:solidFill>
-                  <a:srgbClr val="626669"/>
-                </a:solidFill>
-                <a:latin typeface="Noto Sans"/>
-                <a:ea typeface="Noto Sans CJK JP"/>
-                <a:cs typeface="Noto Sans"/>
-                <a:hlinkClick r:id="rId2"/>
-              </a:rPr>
-              <a:t>https://github.com/xiaobu-coai/BUSTM</a:t>
-            </a:r>
-          </a:p>
-          <a:p>
-            <a:pPr>
-              <a:lnSpc>
-                <a:spcPts val="940"/>
-              </a:lnSpc>
-              <a:spcAft>
-                <a:spcPts val="140"/>
-              </a:spcAft>
-              <a:buNone/>
-              <a:defRPr sz="810" b="0">
-                <a:solidFill>
-                  <a:srgbClr val="303437"/>
-                </a:solidFill>
-                <a:latin typeface="Noto Sans"/>
-              </a:defRPr>
-            </a:pPr>
-            <a:r>
-              <a:rPr sz="810" b="0" lang="ja-JP" altLang="en-US">
-                <a:solidFill>
-                  <a:srgbClr val="626669"/>
-                </a:solidFill>
-                <a:latin typeface="Noto Sans"/>
-                <a:ea typeface="Noto Sans CJK JP"/>
-                <a:cs typeface="Noto Sans"/>
-              </a:rPr>
-              <a:t>[2] CLUE team (2021). FewCLUE — README.  </a:t>
-            </a:r>
-            <a:r>
-              <a:rPr sz="810" b="0" lang="ja-JP" altLang="en-US">
-                <a:solidFill>
-                  <a:srgbClr val="626669"/>
-                </a:solidFill>
-                <a:latin typeface="Noto Sans"/>
-                <a:ea typeface="Noto Sans CJK JP"/>
-                <a:cs typeface="Noto Sans"/>
-                <a:hlinkClick r:id="rId4"/>
-              </a:rPr>
-              <a:t>https://github.com/CLUEbenchmark/FewCLUE/blob/main/README.md</a:t>
+              <a:t>Appendix</a:t>
             </a:r>
           </a:p>
         </p:txBody>
@@ -15620,7 +15691,7 @@
                 <a:ea typeface="Noto Sans CJK JP"/>
                 <a:cs typeface="Noto Sans"/>
               </a:rPr>
-              <a:t>まとめ：口語の意味を、少数例で照合する</a:t>
+              <a:t/>
             </a:r>
           </a:p>
         </p:txBody>
@@ -15637,73 +15708,103 @@
         </p:nvSpPr>
         <p:spPr>
           <a:xfrm>
-            <a:off x="594360" y="1463040"/>
-            <a:ext cx="7955279" cy="3044952"/>
+            <a:off x="640080" y="1972511"/>
+            <a:ext cx="7863840" cy="1744980"/>
           </a:xfrm>
         </p:spPr>
         <p:txBody>
-          <a:bodyPr wrap="square" tIns="91440" bIns="91440">
+          <a:bodyPr lIns="0" rIns="0" tIns="0" bIns="0">
             <a:noAutofit/>
           </a:bodyPr>
           <a:lstStyle/>
           <a:p>
-            <a:pPr marL="457200" indent="-355600">
-              <a:lnSpc>
-                <a:spcPts val="2379"/>
-              </a:lnSpc>
-              <a:spcAft>
-                <a:spcPts val="700"/>
-              </a:spcAft>
-              <a:buSzPct val="66500"/>
+            <a:pPr marL="457200" indent="-457200">
+              <a:lnSpc>
+                <a:spcPts val="3660"/>
+              </a:lnSpc>
+              <a:spcAft>
+                <a:spcPts val="1200"/>
+              </a:spcAft>
+              <a:buSzPct val="100000"/>
               <a:buFont typeface="Noto Sans CJK JP"/>
-              <a:buChar char="●"/>
-              <a:defRPr sz="2000" b="0">
-                <a:solidFill>
-                  <a:srgbClr val="303437"/>
-                </a:solidFill>
-                <a:latin typeface="Noto Sans"/>
-              </a:defRPr>
-            </a:pPr>
-            <a:r>
-              <a:rPr sz="2000" b="0" lang="ja-JP" altLang="en-US">
-                <a:solidFill>
-                  <a:srgbClr val="303437"/>
-                </a:solidFill>
-                <a:latin typeface="Noto Sans"/>
-                <a:ea typeface="Noto Sans CJK JP"/>
-                <a:cs typeface="Noto Sans"/>
-              </a:rPr>
-              <a:t>BUSTMは、小布助手に由来する短い中国語発話対の二値判定データ。言い換え、異なる操作、時点や欲求の違いを扱い、学習・開発を各32件から始める。</a:t>
-            </a:r>
-          </a:p>
-          <a:p>
-            <a:pPr marL="457200" indent="-355600">
-              <a:lnSpc>
-                <a:spcPts val="2379"/>
-              </a:lnSpc>
-              <a:spcAft>
-                <a:spcPts val="0"/>
-              </a:spcAft>
-              <a:buSzPct val="66500"/>
+              <a:buAutoNum type="arabicPeriod" startAt="1"/>
+              <a:defRPr sz="3000" b="1">
+                <a:solidFill>
+                  <a:srgbClr val="303437"/>
+                </a:solidFill>
+                <a:latin typeface="Noto Sans"/>
+              </a:defRPr>
+            </a:pPr>
+            <a:r>
+              <a:rPr sz="3000" b="1" lang="ja-JP" altLang="en-US">
+                <a:solidFill>
+                  <a:srgbClr val="303437"/>
+                </a:solidFill>
+                <a:latin typeface="Noto Sans"/>
+                <a:ea typeface="Noto Sans CJK JP"/>
+                <a:cs typeface="Noto Sans"/>
+              </a:rPr>
+              <a:t>追加10対の原文と日本語訳</a:t>
+            </a:r>
+          </a:p>
+          <a:p>
+            <a:pPr marL="457200" indent="-457200">
+              <a:lnSpc>
+                <a:spcPts val="3660"/>
+              </a:lnSpc>
+              <a:spcAft>
+                <a:spcPts val="1200"/>
+              </a:spcAft>
+              <a:buSzPct val="100000"/>
               <a:buFont typeface="Noto Sans CJK JP"/>
-              <a:buChar char="●"/>
-              <a:defRPr sz="2000" b="0">
-                <a:solidFill>
-                  <a:srgbClr val="303437"/>
-                </a:solidFill>
-                <a:latin typeface="Noto Sans"/>
-              </a:defRPr>
-            </a:pPr>
-            <a:r>
-              <a:rPr sz="2000" b="0" lang="ja-JP" altLang="en-US">
-                <a:solidFill>
-                  <a:srgbClr val="303437"/>
-                </a:solidFill>
-                <a:latin typeface="Noto Sans"/>
-                <a:ea typeface="Noto Sans CJK JP"/>
-                <a:cs typeface="Noto Sans"/>
-              </a:rPr>
-              <a:t>FewCLUEの公開テストは1,772件。2021年のEFLの報告正解率は71.8%で、各100問を解いた人間評価は88%。後にCLEVAの短い発話の言い換え判定にも採用された。</a:t>
+              <a:buAutoNum type="arabicPeriod" startAt="2"/>
+              <a:defRPr sz="3000" b="1">
+                <a:solidFill>
+                  <a:srgbClr val="303437"/>
+                </a:solidFill>
+                <a:latin typeface="Noto Sans"/>
+              </a:defRPr>
+            </a:pPr>
+            <a:r>
+              <a:rPr sz="3000" b="1" lang="ja-JP" altLang="en-US">
+                <a:solidFill>
+                  <a:srgbClr val="303437"/>
+                </a:solidFill>
+                <a:latin typeface="Noto Sans"/>
+                <a:ea typeface="Noto Sans CJK JP"/>
+                <a:cs typeface="Noto Sans"/>
+              </a:rPr>
+              <a:t>入力の読み方と利用例</a:t>
+            </a:r>
+          </a:p>
+          <a:p>
+            <a:pPr marL="457200" indent="-457200">
+              <a:lnSpc>
+                <a:spcPts val="3660"/>
+              </a:lnSpc>
+              <a:spcAft>
+                <a:spcPts val="0"/>
+              </a:spcAft>
+              <a:buSzPct val="100000"/>
+              <a:buFont typeface="Noto Sans CJK JP"/>
+              <a:buAutoNum type="arabicPeriod" startAt="3"/>
+              <a:defRPr sz="3000" b="1">
+                <a:solidFill>
+                  <a:srgbClr val="303437"/>
+                </a:solidFill>
+                <a:latin typeface="Noto Sans"/>
+              </a:defRPr>
+            </a:pPr>
+            <a:r>
+              <a:rPr sz="3000" b="1" lang="ja-JP" altLang="en-US">
+                <a:solidFill>
+                  <a:srgbClr val="303437"/>
+                </a:solidFill>
+                <a:latin typeface="Noto Sans"/>
+                <a:ea typeface="Noto Sans CJK JP"/>
+                <a:cs typeface="Noto Sans"/>
+              </a:rPr>
+              <a:t>参考文献</a:t>
             </a:r>
           </a:p>
         </p:txBody>
@@ -15751,135 +15852,7 @@
                 <a:ea typeface="Noto Sans CJK JP"/>
                 <a:cs typeface="Noto Sans"/>
               </a:rPr>
-              <a:t>4. CLEVAでの利用と公開範囲</a:t>
-            </a:r>
-          </a:p>
-        </p:txBody>
-      </p:sp>
-      <p:sp>
-        <p:nvSpPr>
-          <p:cNvPr id="5" name="sources"/>
-          <p:cNvSpPr txBox="1"/>
-          <p:nvPr/>
-        </p:nvSpPr>
-        <p:spPr>
-          <a:xfrm>
-            <a:off x="502920" y="4700016"/>
-            <a:ext cx="8183879" cy="530352"/>
-          </a:xfrm>
-          <a:prstGeom prst="rect">
-            <a:avLst/>
-          </a:prstGeom>
-          <a:noFill/>
-        </p:spPr>
-        <p:txBody>
-          <a:bodyPr wrap="square" lIns="0" rIns="0" tIns="0" bIns="0">
-            <a:noAutofit/>
-          </a:bodyPr>
-          <a:lstStyle/>
-          <a:p>
-            <a:pPr algn="l">
-              <a:lnSpc>
-                <a:spcPts val="940"/>
-              </a:lnSpc>
-              <a:spcBef>
-                <a:spcPts val="0"/>
-              </a:spcBef>
-              <a:spcAft>
-                <a:spcPts val="140"/>
-              </a:spcAft>
-              <a:buNone/>
-              <a:defRPr sz="810" b="0">
-                <a:solidFill>
-                  <a:srgbClr val="303437"/>
-                </a:solidFill>
-                <a:latin typeface="Noto Sans"/>
-              </a:defRPr>
-            </a:pPr>
-            <a:r>
-              <a:rPr sz="810" b="0" lang="ja-JP" altLang="en-US">
-                <a:solidFill>
-                  <a:srgbClr val="626669"/>
-                </a:solidFill>
-                <a:latin typeface="Noto Sans"/>
-                <a:ea typeface="Noto Sans CJK JP"/>
-                <a:cs typeface="Noto Sans"/>
-              </a:rPr>
-              <a:t>[1] Xu et al. (2021). FewCLUE: A Chinese Few-shot Learning Evaluation Benchmark. arXiv:2107.07498v2.</a:t>
-            </a:r>
-            <a:r>
-              <a:rPr sz="810" b="0" lang="ja-JP" altLang="en-US">
-                <a:solidFill>
-                  <a:srgbClr val="626669"/>
-                </a:solidFill>
-                <a:latin typeface="Noto Sans"/>
-                <a:ea typeface="Noto Sans CJK JP"/>
-                <a:cs typeface="Noto Sans"/>
-              </a:rPr>
-              <a:t>  </a:t>
-            </a:r>
-            <a:r>
-              <a:rPr sz="810" b="0" lang="ja-JP" altLang="en-US">
-                <a:solidFill>
-                  <a:srgbClr val="626669"/>
-                </a:solidFill>
-                <a:latin typeface="Noto Sans"/>
-                <a:ea typeface="Noto Sans CJK JP"/>
-                <a:cs typeface="Noto Sans"/>
-                <a:hlinkClick r:id="rId2"/>
-              </a:rPr>
-              <a:t>https://arxiv.org/abs/2107.07498</a:t>
-            </a:r>
-          </a:p>
-          <a:p>
-            <a:pPr>
-              <a:lnSpc>
-                <a:spcPts val="940"/>
-              </a:lnSpc>
-              <a:spcAft>
-                <a:spcPts val="140"/>
-              </a:spcAft>
-              <a:buNone/>
-              <a:defRPr sz="810" b="0">
-                <a:solidFill>
-                  <a:srgbClr val="303437"/>
-                </a:solidFill>
-                <a:latin typeface="Noto Sans"/>
-              </a:defRPr>
-            </a:pPr>
-            <a:r>
-              <a:rPr sz="810" b="0" lang="ja-JP" altLang="en-US">
-                <a:solidFill>
-                  <a:srgbClr val="626669"/>
-                </a:solidFill>
-                <a:latin typeface="Noto Sans"/>
-                <a:ea typeface="Noto Sans CJK JP"/>
-                <a:cs typeface="Noto Sans"/>
-              </a:rPr>
-              <a:t>[2] Li et al. (2023). CLEVA: Chinese Language Models EVAluation Platform. EMNLP: System Demonstrations.</a:t>
-            </a:r>
-            <a:r>
-              <a:rPr sz="810" b="0" lang="ja-JP" altLang="en-US">
-                <a:solidFill>
-                  <a:srgbClr val="626669"/>
-                </a:solidFill>
-                <a:latin typeface="Noto Sans"/>
-                <a:ea typeface="Noto Sans CJK JP"/>
-                <a:cs typeface="Noto Sans"/>
-              </a:rPr>
-              <a:t>  </a:t>
-            </a:r>
-            <a:r>
-              <a:rPr sz="810" b="0" lang="ja-JP" altLang="en-US">
-                <a:solidFill>
-                  <a:srgbClr val="626669"/>
-                </a:solidFill>
-                <a:latin typeface="Noto Sans"/>
-                <a:ea typeface="Noto Sans CJK JP"/>
-                <a:cs typeface="Noto Sans"/>
-                <a:hlinkClick r:id="rId3"/>
-              </a:rPr>
-              <a:t>https://aclanthology.org/2023.emnlp-demo.17/</a:t>
+              <a:t>Appendix: 目次</a:t>
             </a:r>
           </a:p>
         </p:txBody>
@@ -16088,7 +16061,7 @@
                 <a:ea typeface="Noto Sans CJK JP"/>
                 <a:cs typeface="Noto Sans"/>
               </a:rPr>
-              <a:t>CLEVAでの利用と公開範囲</a:t>
+              <a:t>公開配布と利用条件</a:t>
             </a:r>
           </a:p>
         </p:txBody>
@@ -16150,347 +16123,6 @@
 </file>
 
 <file path=ppt/slides/slide30.xml><?xml version="1.0" encoding="utf-8"?>
-<p:sld xmlns:a="http://schemas.openxmlformats.org/drawingml/2006/main" xmlns:p="http://schemas.openxmlformats.org/presentationml/2006/main" xmlns:r="http://schemas.openxmlformats.org/officeDocument/2006/relationships">
-  <p:cSld>
-    <p:spTree>
-      <p:nvGrpSpPr>
-        <p:cNvPr id="1" name=""/>
-        <p:cNvGrpSpPr/>
-        <p:nvPr/>
-      </p:nvGrpSpPr>
-      <p:grpSpPr/>
-      <p:sp>
-        <p:nvSpPr>
-          <p:cNvPr id="2" name="Title 1"/>
-          <p:cNvSpPr>
-            <a:spLocks noGrp="1"/>
-          </p:cNvSpPr>
-          <p:nvPr>
-            <p:ph type="title"/>
-          </p:nvPr>
-        </p:nvSpPr>
-        <p:spPr>
-          <a:xfrm>
-            <a:off x="548640" y="2484835"/>
-            <a:ext cx="8046720" cy="585216"/>
-          </a:xfrm>
-        </p:spPr>
-        <p:txBody>
-          <a:bodyPr wrap="square" lIns="0" rIns="0" tIns="0" bIns="0" anchor="ctr">
-            <a:noAutofit/>
-          </a:bodyPr>
-          <a:lstStyle/>
-          <a:p>
-            <a:pPr algn="ctr">
-              <a:lnSpc>
-                <a:spcPct val="110000"/>
-              </a:lnSpc>
-              <a:buNone/>
-              <a:defRPr sz="3600" b="0">
-                <a:solidFill>
-                  <a:srgbClr val="303437"/>
-                </a:solidFill>
-                <a:latin typeface="Noto Sans"/>
-              </a:defRPr>
-            </a:pPr>
-            <a:r>
-              <a:rPr sz="3600" b="1" lang="ja-JP" altLang="en-US">
-                <a:solidFill>
-                  <a:srgbClr val="303437"/>
-                </a:solidFill>
-                <a:latin typeface="Noto Sans"/>
-                <a:ea typeface="Noto Sans CJK JP"/>
-                <a:cs typeface="Noto Sans"/>
-              </a:rPr>
-              <a:t>Appendix</a:t>
-            </a:r>
-          </a:p>
-        </p:txBody>
-      </p:sp>
-      <p:sp>
-        <p:nvSpPr>
-          <p:cNvPr id="3" name="Title 2"/>
-          <p:cNvSpPr>
-            <a:spLocks noGrp="1"/>
-          </p:cNvSpPr>
-          <p:nvPr>
-            <p:ph type="title" idx="2"/>
-          </p:nvPr>
-        </p:nvSpPr>
-        <p:spPr>
-          <a:xfrm>
-            <a:off x="75895" y="0"/>
-            <a:ext cx="8115300" cy="480060"/>
-          </a:xfrm>
-        </p:spPr>
-        <p:txBody>
-          <a:bodyPr wrap="square" lIns="0" rIns="0" tIns="0" bIns="0" anchor="ctr">
-            <a:noAutofit/>
-          </a:bodyPr>
-          <a:lstStyle/>
-          <a:p>
-            <a:pPr algn="l">
-              <a:lnSpc>
-                <a:spcPct val="110000"/>
-              </a:lnSpc>
-              <a:buNone/>
-              <a:defRPr sz="1400" b="0">
-                <a:solidFill>
-                  <a:srgbClr val="303437"/>
-                </a:solidFill>
-                <a:latin typeface="Noto Sans"/>
-              </a:defRPr>
-            </a:pPr>
-            <a:r>
-              <a:rPr sz="1400" b="1" lang="ja-JP" altLang="en-US">
-                <a:solidFill>
-                  <a:srgbClr val="FFFEF8"/>
-                </a:solidFill>
-                <a:latin typeface="Noto Sans"/>
-                <a:ea typeface="Noto Sans CJK JP"/>
-                <a:cs typeface="Noto Sans"/>
-              </a:rPr>
-              <a:t>Appendix</a:t>
-            </a:r>
-          </a:p>
-        </p:txBody>
-      </p:sp>
-    </p:spTree>
-  </p:cSld>
-  <p:clrMapOvr>
-    <a:masterClrMapping/>
-  </p:clrMapOvr>
-</p:sld>
-</file>
-
-<file path=ppt/slides/slide31.xml><?xml version="1.0" encoding="utf-8"?>
-<p:sld xmlns:a="http://schemas.openxmlformats.org/drawingml/2006/main" xmlns:p="http://schemas.openxmlformats.org/presentationml/2006/main" xmlns:r="http://schemas.openxmlformats.org/officeDocument/2006/relationships">
-  <p:cSld>
-    <p:spTree>
-      <p:nvGrpSpPr>
-        <p:cNvPr id="1" name=""/>
-        <p:cNvGrpSpPr/>
-        <p:nvPr/>
-      </p:nvGrpSpPr>
-      <p:grpSpPr/>
-      <p:sp>
-        <p:nvSpPr>
-          <p:cNvPr id="2" name="Title 1"/>
-          <p:cNvSpPr>
-            <a:spLocks noGrp="1"/>
-          </p:cNvSpPr>
-          <p:nvPr>
-            <p:ph type="title"/>
-          </p:nvPr>
-        </p:nvSpPr>
-        <p:spPr>
-          <a:xfrm>
-            <a:off x="468172" y="650138"/>
-            <a:ext cx="8206740" cy="616305"/>
-          </a:xfrm>
-        </p:spPr>
-        <p:txBody>
-          <a:bodyPr wrap="square" lIns="0" rIns="0" tIns="0" bIns="0">
-            <a:noAutofit/>
-          </a:bodyPr>
-          <a:lstStyle/>
-          <a:p>
-            <a:pPr algn="l">
-              <a:lnSpc>
-                <a:spcPct val="110000"/>
-              </a:lnSpc>
-              <a:buNone/>
-              <a:defRPr sz="2800" b="0">
-                <a:solidFill>
-                  <a:srgbClr val="303437"/>
-                </a:solidFill>
-                <a:latin typeface="Noto Sans"/>
-              </a:defRPr>
-            </a:pPr>
-            <a:r>
-              <a:rPr sz="2800" b="1" lang="ja-JP" altLang="en-US">
-                <a:solidFill>
-                  <a:srgbClr val="303437"/>
-                </a:solidFill>
-                <a:latin typeface="Noto Sans"/>
-                <a:ea typeface="Noto Sans CJK JP"/>
-                <a:cs typeface="Noto Sans"/>
-              </a:rPr>
-              <a:t/>
-            </a:r>
-          </a:p>
-        </p:txBody>
-      </p:sp>
-      <p:sp>
-        <p:nvSpPr>
-          <p:cNvPr id="3" name="Text Placeholder 2"/>
-          <p:cNvSpPr>
-            <a:spLocks noGrp="1"/>
-          </p:cNvSpPr>
-          <p:nvPr>
-            <p:ph type="body" idx="1"/>
-          </p:nvPr>
-        </p:nvSpPr>
-        <p:spPr>
-          <a:xfrm>
-            <a:off x="640080" y="1972511"/>
-            <a:ext cx="7863840" cy="1744980"/>
-          </a:xfrm>
-        </p:spPr>
-        <p:txBody>
-          <a:bodyPr lIns="0" rIns="0" tIns="0" bIns="0">
-            <a:noAutofit/>
-          </a:bodyPr>
-          <a:lstStyle/>
-          <a:p>
-            <a:pPr marL="457200" indent="-457200">
-              <a:lnSpc>
-                <a:spcPts val="3660"/>
-              </a:lnSpc>
-              <a:spcAft>
-                <a:spcPts val="1200"/>
-              </a:spcAft>
-              <a:buSzPct val="100000"/>
-              <a:buFont typeface="Noto Sans CJK JP"/>
-              <a:buAutoNum type="arabicPeriod" startAt="1"/>
-              <a:defRPr sz="3000" b="1">
-                <a:solidFill>
-                  <a:srgbClr val="303437"/>
-                </a:solidFill>
-                <a:latin typeface="Noto Sans"/>
-              </a:defRPr>
-            </a:pPr>
-            <a:r>
-              <a:rPr sz="3000" b="1" lang="ja-JP" altLang="en-US">
-                <a:solidFill>
-                  <a:srgbClr val="303437"/>
-                </a:solidFill>
-                <a:latin typeface="Noto Sans"/>
-                <a:ea typeface="Noto Sans CJK JP"/>
-                <a:cs typeface="Noto Sans"/>
-              </a:rPr>
-              <a:t>追加10対の原文と日本語訳</a:t>
-            </a:r>
-          </a:p>
-          <a:p>
-            <a:pPr marL="457200" indent="-457200">
-              <a:lnSpc>
-                <a:spcPts val="3660"/>
-              </a:lnSpc>
-              <a:spcAft>
-                <a:spcPts val="1200"/>
-              </a:spcAft>
-              <a:buSzPct val="100000"/>
-              <a:buFont typeface="Noto Sans CJK JP"/>
-              <a:buAutoNum type="arabicPeriod" startAt="2"/>
-              <a:defRPr sz="3000" b="1">
-                <a:solidFill>
-                  <a:srgbClr val="303437"/>
-                </a:solidFill>
-                <a:latin typeface="Noto Sans"/>
-              </a:defRPr>
-            </a:pPr>
-            <a:r>
-              <a:rPr sz="3000" b="1" lang="ja-JP" altLang="en-US">
-                <a:solidFill>
-                  <a:srgbClr val="303437"/>
-                </a:solidFill>
-                <a:latin typeface="Noto Sans"/>
-                <a:ea typeface="Noto Sans CJK JP"/>
-                <a:cs typeface="Noto Sans"/>
-              </a:rPr>
-              <a:t>入力の読み方と二択への変換</a:t>
-            </a:r>
-          </a:p>
-          <a:p>
-            <a:pPr marL="457200" indent="-457200">
-              <a:lnSpc>
-                <a:spcPts val="3660"/>
-              </a:lnSpc>
-              <a:spcAft>
-                <a:spcPts val="0"/>
-              </a:spcAft>
-              <a:buSzPct val="100000"/>
-              <a:buFont typeface="Noto Sans CJK JP"/>
-              <a:buAutoNum type="arabicPeriod" startAt="3"/>
-              <a:defRPr sz="3000" b="1">
-                <a:solidFill>
-                  <a:srgbClr val="303437"/>
-                </a:solidFill>
-                <a:latin typeface="Noto Sans"/>
-              </a:defRPr>
-            </a:pPr>
-            <a:r>
-              <a:rPr sz="3000" b="1" lang="ja-JP" altLang="en-US">
-                <a:solidFill>
-                  <a:srgbClr val="303437"/>
-                </a:solidFill>
-                <a:latin typeface="Noto Sans"/>
-                <a:ea typeface="Noto Sans CJK JP"/>
-                <a:cs typeface="Noto Sans"/>
-              </a:rPr>
-              <a:t>参考文献</a:t>
-            </a:r>
-          </a:p>
-        </p:txBody>
-      </p:sp>
-      <p:sp>
-        <p:nvSpPr>
-          <p:cNvPr id="4" name="Title 3"/>
-          <p:cNvSpPr>
-            <a:spLocks noGrp="1"/>
-          </p:cNvSpPr>
-          <p:nvPr>
-            <p:ph type="title" idx="2"/>
-          </p:nvPr>
-        </p:nvSpPr>
-        <p:spPr>
-          <a:xfrm>
-            <a:off x="75895" y="0"/>
-            <a:ext cx="8115300" cy="480060"/>
-          </a:xfrm>
-        </p:spPr>
-        <p:txBody>
-          <a:bodyPr wrap="square" lIns="0" rIns="0" tIns="0" bIns="0" anchor="ctr">
-            <a:noAutofit/>
-          </a:bodyPr>
-          <a:lstStyle/>
-          <a:p>
-            <a:pPr algn="l">
-              <a:lnSpc>
-                <a:spcPct val="110000"/>
-              </a:lnSpc>
-              <a:buNone/>
-              <a:defRPr sz="1400" b="0">
-                <a:solidFill>
-                  <a:srgbClr val="303437"/>
-                </a:solidFill>
-                <a:latin typeface="Noto Sans"/>
-              </a:defRPr>
-            </a:pPr>
-            <a:r>
-              <a:rPr sz="1400" b="1" lang="ja-JP" altLang="en-US">
-                <a:solidFill>
-                  <a:srgbClr val="FFFEF8"/>
-                </a:solidFill>
-                <a:latin typeface="Noto Sans"/>
-                <a:ea typeface="Noto Sans CJK JP"/>
-                <a:cs typeface="Noto Sans"/>
-              </a:rPr>
-              <a:t>Appendix: 目次</a:t>
-            </a:r>
-          </a:p>
-        </p:txBody>
-      </p:sp>
-    </p:spTree>
-  </p:cSld>
-  <p:clrMapOvr>
-    <a:masterClrMapping/>
-  </p:clrMapOvr>
-</p:sld>
-</file>
-
-<file path=ppt/slides/slide32.xml><?xml version="1.0" encoding="utf-8"?>
 <p:sld xmlns:a="http://schemas.openxmlformats.org/drawingml/2006/main" xmlns:p="http://schemas.openxmlformats.org/presentationml/2006/main" xmlns:r="http://schemas.openxmlformats.org/officeDocument/2006/relationships">
   <p:cSld>
     <p:spTree>
@@ -17158,7 +16790,7 @@
 </p:sld>
 </file>
 
-<file path=ppt/slides/slide33.xml><?xml version="1.0" encoding="utf-8"?>
+<file path=ppt/slides/slide31.xml><?xml version="1.0" encoding="utf-8"?>
 <p:sld xmlns:a="http://schemas.openxmlformats.org/drawingml/2006/main" xmlns:p="http://schemas.openxmlformats.org/presentationml/2006/main" xmlns:r="http://schemas.openxmlformats.org/officeDocument/2006/relationships">
   <p:cSld>
     <p:spTree>
@@ -17826,7 +17458,7 @@
 </p:sld>
 </file>
 
-<file path=ppt/slides/slide34.xml><?xml version="1.0" encoding="utf-8"?>
+<file path=ppt/slides/slide32.xml><?xml version="1.0" encoding="utf-8"?>
 <p:sld xmlns:a="http://schemas.openxmlformats.org/drawingml/2006/main" xmlns:p="http://schemas.openxmlformats.org/presentationml/2006/main" xmlns:r="http://schemas.openxmlformats.org/officeDocument/2006/relationships">
   <p:cSld>
     <p:spTree>
@@ -18494,7 +18126,7 @@
 </p:sld>
 </file>
 
-<file path=ppt/slides/slide35.xml><?xml version="1.0" encoding="utf-8"?>
+<file path=ppt/slides/slide33.xml><?xml version="1.0" encoding="utf-8"?>
 <p:sld xmlns:a="http://schemas.openxmlformats.org/drawingml/2006/main" xmlns:p="http://schemas.openxmlformats.org/presentationml/2006/main" xmlns:r="http://schemas.openxmlformats.org/officeDocument/2006/relationships">
   <p:cSld>
     <p:spTree>
@@ -19162,7 +18794,7 @@
 </p:sld>
 </file>
 
-<file path=ppt/slides/slide36.xml><?xml version="1.0" encoding="utf-8"?>
+<file path=ppt/slides/slide34.xml><?xml version="1.0" encoding="utf-8"?>
 <p:sld xmlns:a="http://schemas.openxmlformats.org/drawingml/2006/main" xmlns:p="http://schemas.openxmlformats.org/presentationml/2006/main" xmlns:r="http://schemas.openxmlformats.org/officeDocument/2006/relationships">
   <p:cSld>
     <p:spTree>
@@ -19830,7 +19462,7 @@
 </p:sld>
 </file>
 
-<file path=ppt/slides/slide37.xml><?xml version="1.0" encoding="utf-8"?>
+<file path=ppt/slides/slide35.xml><?xml version="1.0" encoding="utf-8"?>
 <p:sld xmlns:a="http://schemas.openxmlformats.org/drawingml/2006/main" xmlns:p="http://schemas.openxmlformats.org/presentationml/2006/main" xmlns:r="http://schemas.openxmlformats.org/officeDocument/2006/relationships">
   <p:cSld>
     <p:spTree>
@@ -20498,7 +20130,7 @@
 </p:sld>
 </file>
 
-<file path=ppt/slides/slide38.xml><?xml version="1.0" encoding="utf-8"?>
+<file path=ppt/slides/slide36.xml><?xml version="1.0" encoding="utf-8"?>
 <p:sld xmlns:a="http://schemas.openxmlformats.org/drawingml/2006/main" xmlns:p="http://schemas.openxmlformats.org/presentationml/2006/main" xmlns:r="http://schemas.openxmlformats.org/officeDocument/2006/relationships">
   <p:cSld>
     <p:spTree>
@@ -21166,7 +20798,7 @@
 </p:sld>
 </file>
 
-<file path=ppt/slides/slide39.xml><?xml version="1.0" encoding="utf-8"?>
+<file path=ppt/slides/slide37.xml><?xml version="1.0" encoding="utf-8"?>
 <p:sld xmlns:a="http://schemas.openxmlformats.org/drawingml/2006/main" xmlns:p="http://schemas.openxmlformats.org/presentationml/2006/main" xmlns:r="http://schemas.openxmlformats.org/officeDocument/2006/relationships">
   <p:cSld>
     <p:spTree>
@@ -21834,121 +21466,7 @@
 </p:sld>
 </file>
 
-<file path=ppt/slides/slide4.xml><?xml version="1.0" encoding="utf-8"?>
-<p:sld xmlns:a="http://schemas.openxmlformats.org/drawingml/2006/main" xmlns:p="http://schemas.openxmlformats.org/presentationml/2006/main" xmlns:r="http://schemas.openxmlformats.org/officeDocument/2006/relationships">
-  <p:cSld>
-    <p:spTree>
-      <p:nvGrpSpPr>
-        <p:cNvPr id="1" name=""/>
-        <p:cNvGrpSpPr/>
-        <p:nvPr/>
-      </p:nvGrpSpPr>
-      <p:grpSpPr/>
-      <p:sp>
-        <p:nvSpPr>
-          <p:cNvPr id="2" name="Title 1"/>
-          <p:cNvSpPr>
-            <a:spLocks noGrp="1"/>
-          </p:cNvSpPr>
-          <p:nvPr>
-            <p:ph type="title"/>
-          </p:nvPr>
-        </p:nvSpPr>
-        <p:spPr>
-          <a:xfrm>
-            <a:off x="548640" y="2506875"/>
-            <a:ext cx="8046720" cy="585216"/>
-          </a:xfrm>
-        </p:spPr>
-        <p:txBody>
-          <a:bodyPr wrap="square" lIns="0" rIns="0" tIns="0" bIns="0" anchor="ctr">
-            <a:noAutofit/>
-          </a:bodyPr>
-          <a:lstStyle/>
-          <a:p>
-            <a:pPr algn="ctr">
-              <a:lnSpc>
-                <a:spcPct val="110000"/>
-              </a:lnSpc>
-              <a:buNone/>
-              <a:defRPr sz="3600" b="0">
-                <a:solidFill>
-                  <a:srgbClr val="303437"/>
-                </a:solidFill>
-                <a:latin typeface="Noto Sans"/>
-              </a:defRPr>
-            </a:pPr>
-            <a:r>
-              <a:rPr sz="3600" b="1" lang="ja-JP" altLang="en-US">
-                <a:solidFill>
-                  <a:srgbClr val="303437"/>
-                </a:solidFill>
-                <a:latin typeface="Noto Sans"/>
-                <a:ea typeface="Noto Sans CJK JP"/>
-                <a:cs typeface="Noto Sans"/>
-              </a:rPr>
-              <a:t>二つの発話が同じ意味かを判定する</a:t>
-            </a:r>
-          </a:p>
-        </p:txBody>
-      </p:sp>
-      <p:sp>
-        <p:nvSpPr>
-          <p:cNvPr id="3" name="Title 2"/>
-          <p:cNvSpPr>
-            <a:spLocks noGrp="1"/>
-          </p:cNvSpPr>
-          <p:nvPr>
-            <p:ph type="title" idx="2"/>
-          </p:nvPr>
-        </p:nvSpPr>
-        <p:spPr>
-          <a:xfrm>
-            <a:off x="75895" y="0"/>
-            <a:ext cx="8115300" cy="480060"/>
-          </a:xfrm>
-        </p:spPr>
-        <p:txBody>
-          <a:bodyPr wrap="square" lIns="0" rIns="0" tIns="0" bIns="0" anchor="ctr">
-            <a:noAutofit/>
-          </a:bodyPr>
-          <a:lstStyle/>
-          <a:p>
-            <a:pPr algn="l">
-              <a:lnSpc>
-                <a:spcPct val="110000"/>
-              </a:lnSpc>
-              <a:buNone/>
-              <a:defRPr sz="1400" b="0">
-                <a:solidFill>
-                  <a:srgbClr val="303437"/>
-                </a:solidFill>
-                <a:latin typeface="Noto Sans"/>
-              </a:defRPr>
-            </a:pPr>
-            <a:r>
-              <a:rPr sz="1400" b="1" lang="ja-JP" altLang="en-US">
-                <a:solidFill>
-                  <a:srgbClr val="FFFEF8"/>
-                </a:solidFill>
-                <a:latin typeface="Noto Sans"/>
-                <a:ea typeface="Noto Sans CJK JP"/>
-                <a:cs typeface="Noto Sans"/>
-              </a:rPr>
-              <a:t>1. 二つの発話が同じ意味かを判定する</a:t>
-            </a:r>
-          </a:p>
-        </p:txBody>
-      </p:sp>
-    </p:spTree>
-  </p:cSld>
-  <p:clrMapOvr>
-    <a:masterClrMapping/>
-  </p:clrMapOvr>
-</p:sld>
-</file>
-
-<file path=ppt/slides/slide40.xml><?xml version="1.0" encoding="utf-8"?>
+<file path=ppt/slides/slide38.xml><?xml version="1.0" encoding="utf-8"?>
 <p:sld xmlns:a="http://schemas.openxmlformats.org/drawingml/2006/main" xmlns:p="http://schemas.openxmlformats.org/presentationml/2006/main" xmlns:r="http://schemas.openxmlformats.org/officeDocument/2006/relationships">
   <p:cSld>
     <p:spTree>
@@ -22616,7 +22134,7 @@
 </p:sld>
 </file>
 
-<file path=ppt/slides/slide41.xml><?xml version="1.0" encoding="utf-8"?>
+<file path=ppt/slides/slide39.xml><?xml version="1.0" encoding="utf-8"?>
 <p:sld xmlns:a="http://schemas.openxmlformats.org/drawingml/2006/main" xmlns:p="http://schemas.openxmlformats.org/presentationml/2006/main" xmlns:r="http://schemas.openxmlformats.org/officeDocument/2006/relationships">
   <p:cSld>
     <p:spTree>
@@ -23284,7 +22802,7 @@
 </p:sld>
 </file>
 
-<file path=ppt/slides/slide42.xml><?xml version="1.0" encoding="utf-8"?>
+<file path=ppt/slides/slide4.xml><?xml version="1.0" encoding="utf-8"?>
 <p:sld xmlns:a="http://schemas.openxmlformats.org/drawingml/2006/main" xmlns:p="http://schemas.openxmlformats.org/presentationml/2006/main" xmlns:r="http://schemas.openxmlformats.org/officeDocument/2006/relationships">
   <p:cSld>
     <p:spTree>
@@ -23337,7 +22855,7 @@
                 <a:ea typeface="Noto Sans CJK JP"/>
                 <a:cs typeface="Noto Sans"/>
               </a:rPr>
-              <a:t>入力の読み方と二択への変換</a:t>
+              <a:t>二つの発話が同じ意味かを判定する</a:t>
             </a:r>
           </a:p>
         </p:txBody>
@@ -23385,7 +22903,7 @@
                 <a:ea typeface="Noto Sans CJK JP"/>
                 <a:cs typeface="Noto Sans"/>
               </a:rPr>
-              <a:t>Appendix: 2. 入力の読み方と二択への変換</a:t>
+              <a:t>1. 二つの発話が同じ意味かを判定する</a:t>
             </a:r>
           </a:p>
         </p:txBody>
@@ -23398,7 +22916,121 @@
 </p:sld>
 </file>
 
-<file path=ppt/slides/slide47.xml><?xml version="1.0" encoding="utf-8"?>
+<file path=ppt/slides/slide40.xml><?xml version="1.0" encoding="utf-8"?>
+<p:sld xmlns:a="http://schemas.openxmlformats.org/drawingml/2006/main" xmlns:p="http://schemas.openxmlformats.org/presentationml/2006/main" xmlns:r="http://schemas.openxmlformats.org/officeDocument/2006/relationships">
+  <p:cSld>
+    <p:spTree>
+      <p:nvGrpSpPr>
+        <p:cNvPr id="1" name=""/>
+        <p:cNvGrpSpPr/>
+        <p:nvPr/>
+      </p:nvGrpSpPr>
+      <p:grpSpPr/>
+      <p:sp>
+        <p:nvSpPr>
+          <p:cNvPr id="2" name="Title 1"/>
+          <p:cNvSpPr>
+            <a:spLocks noGrp="1"/>
+          </p:cNvSpPr>
+          <p:nvPr>
+            <p:ph type="title"/>
+          </p:nvPr>
+        </p:nvSpPr>
+        <p:spPr>
+          <a:xfrm>
+            <a:off x="548640" y="2506875"/>
+            <a:ext cx="8046720" cy="585216"/>
+          </a:xfrm>
+        </p:spPr>
+        <p:txBody>
+          <a:bodyPr wrap="square" lIns="0" rIns="0" tIns="0" bIns="0" anchor="ctr">
+            <a:noAutofit/>
+          </a:bodyPr>
+          <a:lstStyle/>
+          <a:p>
+            <a:pPr algn="ctr">
+              <a:lnSpc>
+                <a:spcPct val="110000"/>
+              </a:lnSpc>
+              <a:buNone/>
+              <a:defRPr sz="3600" b="0">
+                <a:solidFill>
+                  <a:srgbClr val="303437"/>
+                </a:solidFill>
+                <a:latin typeface="Noto Sans"/>
+              </a:defRPr>
+            </a:pPr>
+            <a:r>
+              <a:rPr sz="3600" b="1" lang="ja-JP" altLang="en-US">
+                <a:solidFill>
+                  <a:srgbClr val="303437"/>
+                </a:solidFill>
+                <a:latin typeface="Noto Sans"/>
+                <a:ea typeface="Noto Sans CJK JP"/>
+                <a:cs typeface="Noto Sans"/>
+              </a:rPr>
+              <a:t>入力の読み方と利用例</a:t>
+            </a:r>
+          </a:p>
+        </p:txBody>
+      </p:sp>
+      <p:sp>
+        <p:nvSpPr>
+          <p:cNvPr id="3" name="Title 2"/>
+          <p:cNvSpPr>
+            <a:spLocks noGrp="1"/>
+          </p:cNvSpPr>
+          <p:nvPr>
+            <p:ph type="title" idx="2"/>
+          </p:nvPr>
+        </p:nvSpPr>
+        <p:spPr>
+          <a:xfrm>
+            <a:off x="75895" y="0"/>
+            <a:ext cx="8115300" cy="480060"/>
+          </a:xfrm>
+        </p:spPr>
+        <p:txBody>
+          <a:bodyPr wrap="square" lIns="0" rIns="0" tIns="0" bIns="0" anchor="ctr">
+            <a:noAutofit/>
+          </a:bodyPr>
+          <a:lstStyle/>
+          <a:p>
+            <a:pPr algn="l">
+              <a:lnSpc>
+                <a:spcPct val="110000"/>
+              </a:lnSpc>
+              <a:buNone/>
+              <a:defRPr sz="1400" b="0">
+                <a:solidFill>
+                  <a:srgbClr val="303437"/>
+                </a:solidFill>
+                <a:latin typeface="Noto Sans"/>
+              </a:defRPr>
+            </a:pPr>
+            <a:r>
+              <a:rPr sz="1400" b="1" lang="ja-JP" altLang="en-US">
+                <a:solidFill>
+                  <a:srgbClr val="FFFEF8"/>
+                </a:solidFill>
+                <a:latin typeface="Noto Sans"/>
+                <a:ea typeface="Noto Sans CJK JP"/>
+                <a:cs typeface="Noto Sans"/>
+              </a:rPr>
+              <a:t>Appendix: 2. 入力の読み方と利用例</a:t>
+            </a:r>
+          </a:p>
+        </p:txBody>
+      </p:sp>
+    </p:spTree>
+  </p:cSld>
+  <p:clrMapOvr>
+    <a:masterClrMapping/>
+  </p:clrMapOvr>
+</p:sld>
+</file>
+
+<file path=ppt/slides/slide41.xml><?xml version="1.0" encoding="utf-8"?>
 <p:sld xmlns:a="http://schemas.openxmlformats.org/drawingml/2006/main" xmlns:p="http://schemas.openxmlformats.org/presentationml/2006/main" xmlns:r="http://schemas.openxmlformats.org/officeDocument/2006/relationships">
   <p:cSld>
     <p:spTree>
@@ -23499,7 +23131,7 @@
                 <a:ea typeface="Noto Sans CJK JP"/>
                 <a:cs typeface="Noto Sans"/>
               </a:rPr>
-              <a:t>Appendix: 2. 入力の読み方と二択への変換</a:t>
+              <a:t>Appendix: 2. 入力の読み方と利用例</a:t>
             </a:r>
           </a:p>
         </p:txBody>
@@ -23714,7 +23346,7 @@
 </p:sld>
 </file>
 
-<file path=ppt/slides/slide48.xml><?xml version="1.0" encoding="utf-8"?>
+<file path=ppt/slides/slide42.xml><?xml version="1.0" encoding="utf-8"?>
 <p:sld xmlns:a="http://schemas.openxmlformats.org/drawingml/2006/main" xmlns:p="http://schemas.openxmlformats.org/presentationml/2006/main" xmlns:r="http://schemas.openxmlformats.org/officeDocument/2006/relationships">
   <p:cSld>
     <p:spTree>
@@ -23767,7 +23399,7 @@
                 <a:ea typeface="Noto Sans CJK JP"/>
                 <a:cs typeface="Noto Sans"/>
               </a:rPr>
-              <a:t>二択形式では「いいえ」「はい」から答える</a:t>
+              <a:t>応用例：二つの発話を二択で尋ねる</a:t>
             </a:r>
           </a:p>
         </p:txBody>
@@ -23815,7 +23447,7 @@
                 <a:ea typeface="Noto Sans CJK JP"/>
                 <a:cs typeface="Noto Sans"/>
               </a:rPr>
-              <a:t>Appendix: 2. 入力の読み方と二択への変換</a:t>
+              <a:t>Appendix: 2. 入力の読み方と利用例</a:t>
             </a:r>
           </a:p>
         </p:txBody>
@@ -24420,6 +24052,1202 @@
 </p:sld>
 </file>
 
+<file path=ppt/slides/slide43.xml><?xml version="1.0" encoding="utf-8"?>
+<p:sld xmlns:a="http://schemas.openxmlformats.org/drawingml/2006/main" xmlns:p="http://schemas.openxmlformats.org/presentationml/2006/main" xmlns:r="http://schemas.openxmlformats.org/officeDocument/2006/relationships">
+  <p:cSld>
+    <p:spTree>
+      <p:nvGrpSpPr>
+        <p:cNvPr id="1" name=""/>
+        <p:cNvGrpSpPr/>
+        <p:nvPr/>
+      </p:nvGrpSpPr>
+      <p:grpSpPr/>
+      <p:sp>
+        <p:nvSpPr>
+          <p:cNvPr id="2" name="Title 1"/>
+          <p:cNvSpPr>
+            <a:spLocks noGrp="1"/>
+          </p:cNvSpPr>
+          <p:nvPr>
+            <p:ph type="title"/>
+          </p:nvPr>
+        </p:nvSpPr>
+        <p:spPr>
+          <a:xfrm>
+            <a:off x="548640" y="2506875"/>
+            <a:ext cx="8046720" cy="585216"/>
+          </a:xfrm>
+        </p:spPr>
+        <p:txBody>
+          <a:bodyPr wrap="square" lIns="0" rIns="0" tIns="0" bIns="0" anchor="ctr">
+            <a:noAutofit/>
+          </a:bodyPr>
+          <a:lstStyle/>
+          <a:p>
+            <a:pPr algn="ctr">
+              <a:lnSpc>
+                <a:spcPct val="110000"/>
+              </a:lnSpc>
+              <a:buNone/>
+              <a:defRPr sz="3600" b="0">
+                <a:solidFill>
+                  <a:srgbClr val="303437"/>
+                </a:solidFill>
+                <a:latin typeface="Noto Sans"/>
+              </a:defRPr>
+            </a:pPr>
+            <a:r>
+              <a:rPr sz="3600" b="1" lang="ja-JP" altLang="en-US">
+                <a:solidFill>
+                  <a:srgbClr val="303437"/>
+                </a:solidFill>
+                <a:latin typeface="Noto Sans"/>
+                <a:ea typeface="Noto Sans CJK JP"/>
+                <a:cs typeface="Noto Sans"/>
+              </a:rPr>
+              <a:t>参考文献</a:t>
+            </a:r>
+          </a:p>
+        </p:txBody>
+      </p:sp>
+      <p:sp>
+        <p:nvSpPr>
+          <p:cNvPr id="3" name="Title 2"/>
+          <p:cNvSpPr>
+            <a:spLocks noGrp="1"/>
+          </p:cNvSpPr>
+          <p:nvPr>
+            <p:ph type="title" idx="2"/>
+          </p:nvPr>
+        </p:nvSpPr>
+        <p:spPr>
+          <a:xfrm>
+            <a:off x="75895" y="0"/>
+            <a:ext cx="8115300" cy="480060"/>
+          </a:xfrm>
+        </p:spPr>
+        <p:txBody>
+          <a:bodyPr wrap="square" lIns="0" rIns="0" tIns="0" bIns="0" anchor="ctr">
+            <a:noAutofit/>
+          </a:bodyPr>
+          <a:lstStyle/>
+          <a:p>
+            <a:pPr algn="l">
+              <a:lnSpc>
+                <a:spcPct val="110000"/>
+              </a:lnSpc>
+              <a:buNone/>
+              <a:defRPr sz="1400" b="0">
+                <a:solidFill>
+                  <a:srgbClr val="303437"/>
+                </a:solidFill>
+                <a:latin typeface="Noto Sans"/>
+              </a:defRPr>
+            </a:pPr>
+            <a:r>
+              <a:rPr sz="1400" b="1" lang="ja-JP" altLang="en-US">
+                <a:solidFill>
+                  <a:srgbClr val="FFFEF8"/>
+                </a:solidFill>
+                <a:latin typeface="Noto Sans"/>
+                <a:ea typeface="Noto Sans CJK JP"/>
+                <a:cs typeface="Noto Sans"/>
+              </a:rPr>
+              <a:t>Appendix: 3. 参考文献</a:t>
+            </a:r>
+          </a:p>
+        </p:txBody>
+      </p:sp>
+    </p:spTree>
+  </p:cSld>
+  <p:clrMapOvr>
+    <a:masterClrMapping/>
+  </p:clrMapOvr>
+</p:sld>
+</file>
+
+<file path=ppt/slides/slide44.xml><?xml version="1.0" encoding="utf-8"?>
+<p:sld xmlns:a="http://schemas.openxmlformats.org/drawingml/2006/main" xmlns:p="http://schemas.openxmlformats.org/presentationml/2006/main" xmlns:r="http://schemas.openxmlformats.org/officeDocument/2006/relationships">
+  <p:cSld>
+    <p:spTree>
+      <p:nvGrpSpPr>
+        <p:cNvPr id="1" name=""/>
+        <p:cNvGrpSpPr/>
+        <p:nvPr/>
+      </p:nvGrpSpPr>
+      <p:grpSpPr/>
+      <p:sp>
+        <p:nvSpPr>
+          <p:cNvPr id="2" name="Title 1"/>
+          <p:cNvSpPr>
+            <a:spLocks noGrp="1"/>
+          </p:cNvSpPr>
+          <p:nvPr>
+            <p:ph type="title"/>
+          </p:nvPr>
+        </p:nvSpPr>
+        <p:spPr>
+          <a:xfrm>
+            <a:off x="468172" y="650138"/>
+            <a:ext cx="8206740" cy="616305"/>
+          </a:xfrm>
+        </p:spPr>
+        <p:txBody>
+          <a:bodyPr wrap="square" lIns="0" rIns="0" tIns="0" bIns="0">
+            <a:noAutofit/>
+          </a:bodyPr>
+          <a:lstStyle/>
+          <a:p>
+            <a:pPr algn="l">
+              <a:lnSpc>
+                <a:spcPct val="110000"/>
+              </a:lnSpc>
+              <a:buNone/>
+              <a:defRPr sz="2800" b="0">
+                <a:solidFill>
+                  <a:srgbClr val="303437"/>
+                </a:solidFill>
+                <a:latin typeface="Noto Sans"/>
+              </a:defRPr>
+            </a:pPr>
+            <a:r>
+              <a:rPr sz="2800" b="1" lang="ja-JP" altLang="en-US">
+                <a:solidFill>
+                  <a:srgbClr val="303437"/>
+                </a:solidFill>
+                <a:latin typeface="Noto Sans"/>
+                <a:ea typeface="Noto Sans CJK JP"/>
+                <a:cs typeface="Noto Sans"/>
+              </a:rPr>
+              <a:t>参考文献</a:t>
+            </a:r>
+          </a:p>
+        </p:txBody>
+      </p:sp>
+      <p:sp>
+        <p:nvSpPr>
+          <p:cNvPr id="3" name="Title 2"/>
+          <p:cNvSpPr>
+            <a:spLocks noGrp="1"/>
+          </p:cNvSpPr>
+          <p:nvPr>
+            <p:ph type="title" idx="2"/>
+          </p:nvPr>
+        </p:nvSpPr>
+        <p:spPr>
+          <a:xfrm>
+            <a:off x="75895" y="0"/>
+            <a:ext cx="8115300" cy="480060"/>
+          </a:xfrm>
+        </p:spPr>
+        <p:txBody>
+          <a:bodyPr wrap="square" lIns="0" rIns="0" tIns="0" bIns="0" anchor="ctr">
+            <a:noAutofit/>
+          </a:bodyPr>
+          <a:lstStyle/>
+          <a:p>
+            <a:pPr algn="l">
+              <a:lnSpc>
+                <a:spcPct val="110000"/>
+              </a:lnSpc>
+              <a:buNone/>
+              <a:defRPr sz="1400" b="0">
+                <a:solidFill>
+                  <a:srgbClr val="303437"/>
+                </a:solidFill>
+                <a:latin typeface="Noto Sans"/>
+              </a:defRPr>
+            </a:pPr>
+            <a:r>
+              <a:rPr sz="1400" b="1" lang="ja-JP" altLang="en-US">
+                <a:solidFill>
+                  <a:srgbClr val="FFFEF8"/>
+                </a:solidFill>
+                <a:latin typeface="Noto Sans"/>
+                <a:ea typeface="Noto Sans CJK JP"/>
+                <a:cs typeface="Noto Sans"/>
+              </a:rPr>
+              <a:t>Appendix: 3. 参考文献</a:t>
+            </a:r>
+          </a:p>
+        </p:txBody>
+      </p:sp>
+      <p:sp>
+        <p:nvSpPr>
+          <p:cNvPr id="4" name="文献 1: BUSTM: OPPO XiaoBu Dialogue Short Text Matching Dataset"/>
+          <p:cNvSpPr txBox="1"/>
+          <p:nvPr/>
+        </p:nvSpPr>
+        <p:spPr>
+          <a:xfrm>
+            <a:off x="548640" y="1463040"/>
+            <a:ext cx="8046720" cy="1574419"/>
+          </a:xfrm>
+          <a:prstGeom prst="rect">
+            <a:avLst/>
+          </a:prstGeom>
+          <a:noFill/>
+        </p:spPr>
+        <p:txBody>
+          <a:bodyPr wrap="square" lIns="0" rIns="0" tIns="0" bIns="0">
+            <a:noAutofit/>
+          </a:bodyPr>
+          <a:lstStyle/>
+          <a:p>
+            <a:pPr algn="l">
+              <a:lnSpc>
+                <a:spcPct val="114000"/>
+              </a:lnSpc>
+              <a:spcBef>
+                <a:spcPts val="0"/>
+              </a:spcBef>
+              <a:spcAft>
+                <a:spcPts val="400"/>
+              </a:spcAft>
+              <a:buNone/>
+              <a:defRPr sz="1850" b="0">
+                <a:solidFill>
+                  <a:srgbClr val="303437"/>
+                </a:solidFill>
+                <a:latin typeface="Noto Sans"/>
+              </a:defRPr>
+            </a:pPr>
+            <a:r>
+              <a:rPr sz="1850" b="1" lang="ja-JP" altLang="en-US">
+                <a:solidFill>
+                  <a:srgbClr val="303437"/>
+                </a:solidFill>
+                <a:latin typeface="Noto Sans"/>
+                <a:ea typeface="Noto Sans CJK JP"/>
+                <a:cs typeface="Noto Sans"/>
+              </a:rPr>
+              <a:t>BUSTM: OPPO XiaoBu Dialogue Short Text Matching Dataset</a:t>
+            </a:r>
+          </a:p>
+          <a:p>
+            <a:pPr algn="l">
+              <a:lnSpc>
+                <a:spcPct val="114000"/>
+              </a:lnSpc>
+              <a:spcBef>
+                <a:spcPts val="0"/>
+              </a:spcBef>
+              <a:spcAft>
+                <a:spcPts val="500"/>
+              </a:spcAft>
+              <a:buNone/>
+              <a:defRPr sz="1250" b="0">
+                <a:solidFill>
+                  <a:srgbClr val="303437"/>
+                </a:solidFill>
+                <a:latin typeface="Noto Sans"/>
+              </a:defRPr>
+            </a:pPr>
+            <a:r>
+              <a:rPr sz="1250" b="0" lang="ja-JP" altLang="en-US">
+                <a:solidFill>
+                  <a:srgbClr val="626669"/>
+                </a:solidFill>
+                <a:latin typeface="Noto Sans"/>
+                <a:ea typeface="Noto Sans CJK JP"/>
+                <a:cs typeface="Noto Sans"/>
+              </a:rPr>
+              <a:t>OPPO XiaoBu Conversational-AI Center · 2021 · 公式公開</a:t>
+            </a:r>
+          </a:p>
+          <a:p>
+            <a:pPr algn="l">
+              <a:lnSpc>
+                <a:spcPct val="114000"/>
+              </a:lnSpc>
+              <a:spcBef>
+                <a:spcPts val="0"/>
+              </a:spcBef>
+              <a:spcAft>
+                <a:spcPts val="400"/>
+              </a:spcAft>
+              <a:buNone/>
+              <a:defRPr sz="1750" b="0">
+                <a:solidFill>
+                  <a:srgbClr val="303437"/>
+                </a:solidFill>
+                <a:latin typeface="Noto Sans"/>
+              </a:defRPr>
+            </a:pPr>
+            <a:r>
+              <a:rPr sz="1750" b="0" lang="ja-JP" altLang="en-US">
+                <a:solidFill>
+                  <a:srgbClr val="303437"/>
+                </a:solidFill>
+                <a:latin typeface="Noto Sans"/>
+                <a:ea typeface="Noto Sans CJK JP"/>
+                <a:cs typeface="Noto Sans"/>
+              </a:rPr>
+              <a:t>スマートフォンとIoT機器向けアシスタントの短文意味照合データ。FewCLUE配布へのリンクと引用方法を示す。</a:t>
+            </a:r>
+          </a:p>
+          <a:p>
+            <a:pPr algn="l">
+              <a:lnSpc>
+                <a:spcPct val="114000"/>
+              </a:lnSpc>
+              <a:spcBef>
+                <a:spcPts val="0"/>
+              </a:spcBef>
+              <a:spcAft>
+                <a:spcPts val="0"/>
+              </a:spcAft>
+              <a:buNone/>
+              <a:defRPr sz="1050" b="0">
+                <a:solidFill>
+                  <a:srgbClr val="303437"/>
+                </a:solidFill>
+                <a:latin typeface="Noto Sans"/>
+              </a:defRPr>
+            </a:pPr>
+            <a:r>
+              <a:rPr sz="1050" b="0" lang="ja-JP" altLang="en-US">
+                <a:solidFill>
+                  <a:srgbClr val="626669"/>
+                </a:solidFill>
+                <a:latin typeface="Noto Sans"/>
+                <a:ea typeface="Noto Sans CJK JP"/>
+                <a:cs typeface="Noto Sans"/>
+                <a:hlinkClick r:id="rId2"/>
+              </a:rPr>
+              <a:t>https://github.com/xiaobu-coai/BUSTM</a:t>
+            </a:r>
+          </a:p>
+        </p:txBody>
+      </p:sp>
+      <p:sp>
+        <p:nvSpPr>
+          <p:cNvPr id="5" name="文献 2: FewCLUE: A Chinese Few-shot Learning Evaluation Benchmark"/>
+          <p:cNvSpPr txBox="1"/>
+          <p:nvPr/>
+        </p:nvSpPr>
+        <p:spPr>
+          <a:xfrm>
+            <a:off x="548640" y="3040507"/>
+            <a:ext cx="8046720" cy="1755394"/>
+          </a:xfrm>
+          <a:prstGeom prst="rect">
+            <a:avLst/>
+          </a:prstGeom>
+          <a:noFill/>
+        </p:spPr>
+        <p:txBody>
+          <a:bodyPr wrap="square" lIns="0" rIns="0" tIns="0" bIns="0">
+            <a:noAutofit/>
+          </a:bodyPr>
+          <a:lstStyle/>
+          <a:p>
+            <a:pPr algn="l">
+              <a:lnSpc>
+                <a:spcPct val="114000"/>
+              </a:lnSpc>
+              <a:spcBef>
+                <a:spcPts val="0"/>
+              </a:spcBef>
+              <a:spcAft>
+                <a:spcPts val="400"/>
+              </a:spcAft>
+              <a:buNone/>
+              <a:defRPr sz="1850" b="0">
+                <a:solidFill>
+                  <a:srgbClr val="303437"/>
+                </a:solidFill>
+                <a:latin typeface="Noto Sans"/>
+              </a:defRPr>
+            </a:pPr>
+            <a:r>
+              <a:rPr sz="1850" b="1" lang="ja-JP" altLang="en-US">
+                <a:solidFill>
+                  <a:srgbClr val="303437"/>
+                </a:solidFill>
+                <a:latin typeface="Noto Sans"/>
+                <a:ea typeface="Noto Sans CJK JP"/>
+                <a:cs typeface="Noto Sans"/>
+              </a:rPr>
+              <a:t>FewCLUE: A Chinese Few-shot Learning Evaluation Benchmark</a:t>
+            </a:r>
+          </a:p>
+          <a:p>
+            <a:pPr algn="l">
+              <a:lnSpc>
+                <a:spcPct val="114000"/>
+              </a:lnSpc>
+              <a:spcBef>
+                <a:spcPts val="0"/>
+              </a:spcBef>
+              <a:spcAft>
+                <a:spcPts val="500"/>
+              </a:spcAft>
+              <a:buNone/>
+              <a:defRPr sz="1250" b="0">
+                <a:solidFill>
+                  <a:srgbClr val="303437"/>
+                </a:solidFill>
+                <a:latin typeface="Noto Sans"/>
+              </a:defRPr>
+            </a:pPr>
+            <a:r>
+              <a:rPr sz="1250" b="0" lang="ja-JP" altLang="en-US">
+                <a:solidFill>
+                  <a:srgbClr val="626669"/>
+                </a:solidFill>
+                <a:latin typeface="Noto Sans"/>
+                <a:ea typeface="Noto Sans CJK JP"/>
+                <a:cs typeface="Noto Sans"/>
+              </a:rPr>
+              <a:t>Liang Xu, Xiaojing Lu, Chenyang Yuan, Xuanwei Zhang, Huilin Xu, Hu Yuan, Guoao Wei, Xiang Pan, Xin Tian, Libo Qin, Hai Hu · 2021 · arXiv:2107.07498v2</a:t>
+            </a:r>
+          </a:p>
+          <a:p>
+            <a:pPr algn="l">
+              <a:lnSpc>
+                <a:spcPct val="114000"/>
+              </a:lnSpc>
+              <a:spcBef>
+                <a:spcPts val="0"/>
+              </a:spcBef>
+              <a:spcAft>
+                <a:spcPts val="400"/>
+              </a:spcAft>
+              <a:buNone/>
+              <a:defRPr sz="1750" b="0">
+                <a:solidFill>
+                  <a:srgbClr val="303437"/>
+                </a:solidFill>
+                <a:latin typeface="Noto Sans"/>
+              </a:defRPr>
+            </a:pPr>
+            <a:r>
+              <a:rPr sz="1750" b="0" lang="ja-JP" altLang="en-US">
+                <a:solidFill>
+                  <a:srgbClr val="303437"/>
+                </a:solidFill>
+                <a:latin typeface="Noto Sans"/>
+                <a:ea typeface="Noto Sans CJK JP"/>
+                <a:cs typeface="Noto Sans"/>
+              </a:rPr>
+              <a:t>中国語の九つの少数例学習課題と、直接微調整・穴埋め形式・含意判定などの比較を報告する。</a:t>
+            </a:r>
+          </a:p>
+          <a:p>
+            <a:pPr algn="l">
+              <a:lnSpc>
+                <a:spcPct val="114000"/>
+              </a:lnSpc>
+              <a:spcBef>
+                <a:spcPts val="0"/>
+              </a:spcBef>
+              <a:spcAft>
+                <a:spcPts val="0"/>
+              </a:spcAft>
+              <a:buNone/>
+              <a:defRPr sz="1050" b="0">
+                <a:solidFill>
+                  <a:srgbClr val="303437"/>
+                </a:solidFill>
+                <a:latin typeface="Noto Sans"/>
+              </a:defRPr>
+            </a:pPr>
+            <a:r>
+              <a:rPr sz="1050" b="0" lang="ja-JP" altLang="en-US">
+                <a:solidFill>
+                  <a:srgbClr val="626669"/>
+                </a:solidFill>
+                <a:latin typeface="Noto Sans"/>
+                <a:ea typeface="Noto Sans CJK JP"/>
+                <a:cs typeface="Noto Sans"/>
+                <a:hlinkClick r:id="rId3"/>
+              </a:rPr>
+              <a:t>https://arxiv.org/abs/2107.07498</a:t>
+            </a:r>
+          </a:p>
+        </p:txBody>
+      </p:sp>
+    </p:spTree>
+  </p:cSld>
+  <p:clrMapOvr>
+    <a:masterClrMapping/>
+  </p:clrMapOvr>
+</p:sld>
+</file>
+
+<file path=ppt/slides/slide45.xml><?xml version="1.0" encoding="utf-8"?>
+<p:sld xmlns:a="http://schemas.openxmlformats.org/drawingml/2006/main" xmlns:p="http://schemas.openxmlformats.org/presentationml/2006/main" xmlns:r="http://schemas.openxmlformats.org/officeDocument/2006/relationships">
+  <p:cSld>
+    <p:spTree>
+      <p:nvGrpSpPr>
+        <p:cNvPr id="1" name=""/>
+        <p:cNvGrpSpPr/>
+        <p:nvPr/>
+      </p:nvGrpSpPr>
+      <p:grpSpPr/>
+      <p:sp>
+        <p:nvSpPr>
+          <p:cNvPr id="2" name="Title 1"/>
+          <p:cNvSpPr>
+            <a:spLocks noGrp="1"/>
+          </p:cNvSpPr>
+          <p:nvPr>
+            <p:ph type="title"/>
+          </p:nvPr>
+        </p:nvSpPr>
+        <p:spPr>
+          <a:xfrm>
+            <a:off x="468172" y="650138"/>
+            <a:ext cx="8206740" cy="616305"/>
+          </a:xfrm>
+        </p:spPr>
+        <p:txBody>
+          <a:bodyPr wrap="square" lIns="0" rIns="0" tIns="0" bIns="0">
+            <a:noAutofit/>
+          </a:bodyPr>
+          <a:lstStyle/>
+          <a:p>
+            <a:pPr algn="l">
+              <a:lnSpc>
+                <a:spcPct val="110000"/>
+              </a:lnSpc>
+              <a:buNone/>
+              <a:defRPr sz="2800" b="0">
+                <a:solidFill>
+                  <a:srgbClr val="303437"/>
+                </a:solidFill>
+                <a:latin typeface="Noto Sans"/>
+              </a:defRPr>
+            </a:pPr>
+            <a:r>
+              <a:rPr sz="2800" b="1" lang="ja-JP" altLang="en-US">
+                <a:solidFill>
+                  <a:srgbClr val="303437"/>
+                </a:solidFill>
+                <a:latin typeface="Noto Sans"/>
+                <a:ea typeface="Noto Sans CJK JP"/>
+                <a:cs typeface="Noto Sans"/>
+              </a:rPr>
+              <a:t>参考文献</a:t>
+            </a:r>
+          </a:p>
+        </p:txBody>
+      </p:sp>
+      <p:sp>
+        <p:nvSpPr>
+          <p:cNvPr id="3" name="Title 2"/>
+          <p:cNvSpPr>
+            <a:spLocks noGrp="1"/>
+          </p:cNvSpPr>
+          <p:nvPr>
+            <p:ph type="title" idx="2"/>
+          </p:nvPr>
+        </p:nvSpPr>
+        <p:spPr>
+          <a:xfrm>
+            <a:off x="75895" y="0"/>
+            <a:ext cx="8115300" cy="480060"/>
+          </a:xfrm>
+        </p:spPr>
+        <p:txBody>
+          <a:bodyPr wrap="square" lIns="0" rIns="0" tIns="0" bIns="0" anchor="ctr">
+            <a:noAutofit/>
+          </a:bodyPr>
+          <a:lstStyle/>
+          <a:p>
+            <a:pPr algn="l">
+              <a:lnSpc>
+                <a:spcPct val="110000"/>
+              </a:lnSpc>
+              <a:buNone/>
+              <a:defRPr sz="1400" b="0">
+                <a:solidFill>
+                  <a:srgbClr val="303437"/>
+                </a:solidFill>
+                <a:latin typeface="Noto Sans"/>
+              </a:defRPr>
+            </a:pPr>
+            <a:r>
+              <a:rPr sz="1400" b="1" lang="ja-JP" altLang="en-US">
+                <a:solidFill>
+                  <a:srgbClr val="FFFEF8"/>
+                </a:solidFill>
+                <a:latin typeface="Noto Sans"/>
+                <a:ea typeface="Noto Sans CJK JP"/>
+                <a:cs typeface="Noto Sans"/>
+              </a:rPr>
+              <a:t>Appendix: 3. 参考文献</a:t>
+            </a:r>
+          </a:p>
+        </p:txBody>
+      </p:sp>
+      <p:sp>
+        <p:nvSpPr>
+          <p:cNvPr id="4" name="文献 1: FewCLUE — Official Dataset Distribution"/>
+          <p:cNvSpPr txBox="1"/>
+          <p:nvPr/>
+        </p:nvSpPr>
+        <p:spPr>
+          <a:xfrm>
+            <a:off x="548640" y="1463040"/>
+            <a:ext cx="8046720" cy="1574419"/>
+          </a:xfrm>
+          <a:prstGeom prst="rect">
+            <a:avLst/>
+          </a:prstGeom>
+          <a:noFill/>
+        </p:spPr>
+        <p:txBody>
+          <a:bodyPr wrap="square" lIns="0" rIns="0" tIns="0" bIns="0">
+            <a:noAutofit/>
+          </a:bodyPr>
+          <a:lstStyle/>
+          <a:p>
+            <a:pPr algn="l">
+              <a:lnSpc>
+                <a:spcPct val="114000"/>
+              </a:lnSpc>
+              <a:spcBef>
+                <a:spcPts val="0"/>
+              </a:spcBef>
+              <a:spcAft>
+                <a:spcPts val="400"/>
+              </a:spcAft>
+              <a:buNone/>
+              <a:defRPr sz="1850" b="0">
+                <a:solidFill>
+                  <a:srgbClr val="303437"/>
+                </a:solidFill>
+                <a:latin typeface="Noto Sans"/>
+              </a:defRPr>
+            </a:pPr>
+            <a:r>
+              <a:rPr sz="1850" b="1" lang="ja-JP" altLang="en-US">
+                <a:solidFill>
+                  <a:srgbClr val="303437"/>
+                </a:solidFill>
+                <a:latin typeface="Noto Sans"/>
+                <a:ea typeface="Noto Sans CJK JP"/>
+                <a:cs typeface="Noto Sans"/>
+              </a:rPr>
+              <a:t>FewCLUE — Official Dataset Distribution</a:t>
+            </a:r>
+          </a:p>
+          <a:p>
+            <a:pPr algn="l">
+              <a:lnSpc>
+                <a:spcPct val="114000"/>
+              </a:lnSpc>
+              <a:spcBef>
+                <a:spcPts val="0"/>
+              </a:spcBef>
+              <a:spcAft>
+                <a:spcPts val="500"/>
+              </a:spcAft>
+              <a:buNone/>
+              <a:defRPr sz="1250" b="0">
+                <a:solidFill>
+                  <a:srgbClr val="303437"/>
+                </a:solidFill>
+                <a:latin typeface="Noto Sans"/>
+              </a:defRPr>
+            </a:pPr>
+            <a:r>
+              <a:rPr sz="1250" b="0" lang="ja-JP" altLang="en-US">
+                <a:solidFill>
+                  <a:srgbClr val="626669"/>
+                </a:solidFill>
+                <a:latin typeface="Noto Sans"/>
+                <a:ea typeface="Noto Sans CJK JP"/>
+                <a:cs typeface="Noto Sans"/>
+              </a:rPr>
+              <a:t>CLUE team · 2021 · 公式配布</a:t>
+            </a:r>
+          </a:p>
+          <a:p>
+            <a:pPr algn="l">
+              <a:lnSpc>
+                <a:spcPct val="114000"/>
+              </a:lnSpc>
+              <a:spcBef>
+                <a:spcPts val="0"/>
+              </a:spcBef>
+              <a:spcAft>
+                <a:spcPts val="400"/>
+              </a:spcAft>
+              <a:buNone/>
+              <a:defRPr sz="1750" b="0">
+                <a:solidFill>
+                  <a:srgbClr val="303437"/>
+                </a:solidFill>
+                <a:latin typeface="Noto Sans"/>
+              </a:defRPr>
+            </a:pPr>
+            <a:r>
+              <a:rPr sz="1750" b="0" lang="ja-JP" altLang="en-US">
+                <a:solidFill>
+                  <a:srgbClr val="303437"/>
+                </a:solidFill>
+                <a:latin typeface="Noto Sans"/>
+                <a:ea typeface="Noto Sans CJK JP"/>
+                <a:cs typeface="Noto Sans"/>
+              </a:rPr>
+              <a:t>32件ずつの学習・開発組、公開正解付きテスト、提出用入力、未ラベル対をJSONL形式で公開する。</a:t>
+            </a:r>
+          </a:p>
+          <a:p>
+            <a:pPr algn="l">
+              <a:lnSpc>
+                <a:spcPct val="114000"/>
+              </a:lnSpc>
+              <a:spcBef>
+                <a:spcPts val="0"/>
+              </a:spcBef>
+              <a:spcAft>
+                <a:spcPts val="0"/>
+              </a:spcAft>
+              <a:buNone/>
+              <a:defRPr sz="1050" b="0">
+                <a:solidFill>
+                  <a:srgbClr val="303437"/>
+                </a:solidFill>
+                <a:latin typeface="Noto Sans"/>
+              </a:defRPr>
+            </a:pPr>
+            <a:r>
+              <a:rPr sz="1050" b="0" lang="ja-JP" altLang="en-US">
+                <a:solidFill>
+                  <a:srgbClr val="626669"/>
+                </a:solidFill>
+                <a:latin typeface="Noto Sans"/>
+                <a:ea typeface="Noto Sans CJK JP"/>
+                <a:cs typeface="Noto Sans"/>
+                <a:hlinkClick r:id="rId2"/>
+              </a:rPr>
+              <a:t>https://github.com/CLUEbenchmark/FewCLUE/tree/main/datasets/bustm</a:t>
+            </a:r>
+          </a:p>
+        </p:txBody>
+      </p:sp>
+      <p:sp>
+        <p:nvSpPr>
+          <p:cNvPr id="5" name="文献 2: FewCLUE — README and Evaluation Protocol"/>
+          <p:cNvSpPr txBox="1"/>
+          <p:nvPr/>
+        </p:nvSpPr>
+        <p:spPr>
+          <a:xfrm>
+            <a:off x="548640" y="3040507"/>
+            <a:ext cx="8046720" cy="1574419"/>
+          </a:xfrm>
+          <a:prstGeom prst="rect">
+            <a:avLst/>
+          </a:prstGeom>
+          <a:noFill/>
+        </p:spPr>
+        <p:txBody>
+          <a:bodyPr wrap="square" lIns="0" rIns="0" tIns="0" bIns="0">
+            <a:noAutofit/>
+          </a:bodyPr>
+          <a:lstStyle/>
+          <a:p>
+            <a:pPr algn="l">
+              <a:lnSpc>
+                <a:spcPct val="114000"/>
+              </a:lnSpc>
+              <a:spcBef>
+                <a:spcPts val="0"/>
+              </a:spcBef>
+              <a:spcAft>
+                <a:spcPts val="400"/>
+              </a:spcAft>
+              <a:buNone/>
+              <a:defRPr sz="1850" b="0">
+                <a:solidFill>
+                  <a:srgbClr val="303437"/>
+                </a:solidFill>
+                <a:latin typeface="Noto Sans"/>
+              </a:defRPr>
+            </a:pPr>
+            <a:r>
+              <a:rPr sz="1850" b="1" lang="ja-JP" altLang="en-US">
+                <a:solidFill>
+                  <a:srgbClr val="303437"/>
+                </a:solidFill>
+                <a:latin typeface="Noto Sans"/>
+                <a:ea typeface="Noto Sans CJK JP"/>
+                <a:cs typeface="Noto Sans"/>
+              </a:rPr>
+              <a:t>FewCLUE — README and Evaluation Protocol</a:t>
+            </a:r>
+          </a:p>
+          <a:p>
+            <a:pPr algn="l">
+              <a:lnSpc>
+                <a:spcPct val="114000"/>
+              </a:lnSpc>
+              <a:spcBef>
+                <a:spcPts val="0"/>
+              </a:spcBef>
+              <a:spcAft>
+                <a:spcPts val="500"/>
+              </a:spcAft>
+              <a:buNone/>
+              <a:defRPr sz="1250" b="0">
+                <a:solidFill>
+                  <a:srgbClr val="303437"/>
+                </a:solidFill>
+                <a:latin typeface="Noto Sans"/>
+              </a:defRPr>
+            </a:pPr>
+            <a:r>
+              <a:rPr sz="1250" b="0" lang="ja-JP" altLang="en-US">
+                <a:solidFill>
+                  <a:srgbClr val="626669"/>
+                </a:solidFill>
+                <a:latin typeface="Noto Sans"/>
+                <a:ea typeface="Noto Sans CJK JP"/>
+                <a:cs typeface="Noto Sans"/>
+              </a:rPr>
+              <a:t>CLUE team · 2021年の実験・コンテスト条件</a:t>
+            </a:r>
+          </a:p>
+          <a:p>
+            <a:pPr algn="l">
+              <a:lnSpc>
+                <a:spcPct val="114000"/>
+              </a:lnSpc>
+              <a:spcBef>
+                <a:spcPts val="0"/>
+              </a:spcBef>
+              <a:spcAft>
+                <a:spcPts val="400"/>
+              </a:spcAft>
+              <a:buNone/>
+              <a:defRPr sz="1750" b="0">
+                <a:solidFill>
+                  <a:srgbClr val="303437"/>
+                </a:solidFill>
+                <a:latin typeface="Noto Sans"/>
+              </a:defRPr>
+            </a:pPr>
+            <a:r>
+              <a:rPr sz="1750" b="0" lang="ja-JP" altLang="en-US">
+                <a:solidFill>
+                  <a:srgbClr val="303437"/>
+                </a:solidFill>
+                <a:latin typeface="Noto Sans"/>
+                <a:ea typeface="Noto Sans CJK JP"/>
+                <a:cs typeface="Noto Sans"/>
+              </a:rPr>
+              <a:t>公開テストと提出用テストの役割、複数学習条件の提出、人間評価とモデル比較、ライセンス欄を示す。</a:t>
+            </a:r>
+          </a:p>
+          <a:p>
+            <a:pPr algn="l">
+              <a:lnSpc>
+                <a:spcPct val="114000"/>
+              </a:lnSpc>
+              <a:spcBef>
+                <a:spcPts val="0"/>
+              </a:spcBef>
+              <a:spcAft>
+                <a:spcPts val="0"/>
+              </a:spcAft>
+              <a:buNone/>
+              <a:defRPr sz="1050" b="0">
+                <a:solidFill>
+                  <a:srgbClr val="303437"/>
+                </a:solidFill>
+                <a:latin typeface="Noto Sans"/>
+              </a:defRPr>
+            </a:pPr>
+            <a:r>
+              <a:rPr sz="1050" b="0" lang="ja-JP" altLang="en-US">
+                <a:solidFill>
+                  <a:srgbClr val="626669"/>
+                </a:solidFill>
+                <a:latin typeface="Noto Sans"/>
+                <a:ea typeface="Noto Sans CJK JP"/>
+                <a:cs typeface="Noto Sans"/>
+                <a:hlinkClick r:id="rId3"/>
+              </a:rPr>
+              <a:t>https://github.com/CLUEbenchmark/FewCLUE/blob/main/README.md</a:t>
+            </a:r>
+          </a:p>
+        </p:txBody>
+      </p:sp>
+    </p:spTree>
+  </p:cSld>
+  <p:clrMapOvr>
+    <a:masterClrMapping/>
+  </p:clrMapOvr>
+</p:sld>
+</file>
+
+<file path=ppt/slides/slide47.xml><?xml version="1.0" encoding="utf-8"?>
+<p:sld xmlns:a="http://schemas.openxmlformats.org/drawingml/2006/main" xmlns:p="http://schemas.openxmlformats.org/presentationml/2006/main" xmlns:r="http://schemas.openxmlformats.org/officeDocument/2006/relationships">
+  <p:cSld>
+    <p:spTree>
+      <p:nvGrpSpPr>
+        <p:cNvPr id="1" name=""/>
+        <p:cNvGrpSpPr/>
+        <p:nvPr/>
+      </p:nvGrpSpPr>
+      <p:grpSpPr/>
+      <p:sp>
+        <p:nvSpPr>
+          <p:cNvPr id="2" name="Title 1"/>
+          <p:cNvSpPr>
+            <a:spLocks noGrp="1"/>
+          </p:cNvSpPr>
+          <p:nvPr>
+            <p:ph type="title"/>
+          </p:nvPr>
+        </p:nvSpPr>
+        <p:spPr>
+          <a:xfrm>
+            <a:off x="468172" y="650138"/>
+            <a:ext cx="8206740" cy="616305"/>
+          </a:xfrm>
+        </p:spPr>
+        <p:txBody>
+          <a:bodyPr wrap="square" lIns="0" rIns="0" tIns="0" bIns="0">
+            <a:noAutofit/>
+          </a:bodyPr>
+          <a:lstStyle/>
+          <a:p>
+            <a:pPr algn="l">
+              <a:lnSpc>
+                <a:spcPct val="110000"/>
+              </a:lnSpc>
+              <a:buNone/>
+              <a:defRPr sz="2800" b="0">
+                <a:solidFill>
+                  <a:srgbClr val="303437"/>
+                </a:solidFill>
+                <a:latin typeface="Noto Sans"/>
+              </a:defRPr>
+            </a:pPr>
+            <a:r>
+              <a:rPr sz="2800" b="1" lang="ja-JP" altLang="en-US">
+                <a:solidFill>
+                  <a:srgbClr val="303437"/>
+                </a:solidFill>
+                <a:latin typeface="Noto Sans"/>
+                <a:ea typeface="Noto Sans CJK JP"/>
+                <a:cs typeface="Noto Sans"/>
+              </a:rPr>
+              <a:t>参考文献</a:t>
+            </a:r>
+          </a:p>
+        </p:txBody>
+      </p:sp>
+      <p:sp>
+        <p:nvSpPr>
+          <p:cNvPr id="3" name="Title 2"/>
+          <p:cNvSpPr>
+            <a:spLocks noGrp="1"/>
+          </p:cNvSpPr>
+          <p:nvPr>
+            <p:ph type="title" idx="2"/>
+          </p:nvPr>
+        </p:nvSpPr>
+        <p:spPr>
+          <a:xfrm>
+            <a:off x="75895" y="0"/>
+            <a:ext cx="8115300" cy="480060"/>
+          </a:xfrm>
+        </p:spPr>
+        <p:txBody>
+          <a:bodyPr wrap="square" lIns="0" rIns="0" tIns="0" bIns="0" anchor="ctr">
+            <a:noAutofit/>
+          </a:bodyPr>
+          <a:lstStyle/>
+          <a:p>
+            <a:pPr algn="l">
+              <a:lnSpc>
+                <a:spcPct val="110000"/>
+              </a:lnSpc>
+              <a:buNone/>
+              <a:defRPr sz="1400" b="0">
+                <a:solidFill>
+                  <a:srgbClr val="303437"/>
+                </a:solidFill>
+                <a:latin typeface="Noto Sans"/>
+              </a:defRPr>
+            </a:pPr>
+            <a:r>
+              <a:rPr sz="1400" b="1" lang="ja-JP" altLang="en-US">
+                <a:solidFill>
+                  <a:srgbClr val="FFFEF8"/>
+                </a:solidFill>
+                <a:latin typeface="Noto Sans"/>
+                <a:ea typeface="Noto Sans CJK JP"/>
+                <a:cs typeface="Noto Sans"/>
+              </a:rPr>
+              <a:t>Appendix: 3. 参考文献</a:t>
+            </a:r>
+          </a:p>
+        </p:txBody>
+      </p:sp>
+      <p:sp>
+        <p:nvSpPr>
+          <p:cNvPr id="4" name="文献 1: pet_bustm.py"/>
+          <p:cNvSpPr txBox="1"/>
+          <p:nvPr/>
+        </p:nvSpPr>
+        <p:spPr>
+          <a:xfrm>
+            <a:off x="548640" y="1463040"/>
+            <a:ext cx="8046720" cy="1574419"/>
+          </a:xfrm>
+          <a:prstGeom prst="rect">
+            <a:avLst/>
+          </a:prstGeom>
+          <a:noFill/>
+        </p:spPr>
+        <p:txBody>
+          <a:bodyPr wrap="square" lIns="0" rIns="0" tIns="0" bIns="0">
+            <a:noAutofit/>
+          </a:bodyPr>
+          <a:lstStyle/>
+          <a:p>
+            <a:pPr algn="l">
+              <a:lnSpc>
+                <a:spcPct val="114000"/>
+              </a:lnSpc>
+              <a:spcBef>
+                <a:spcPts val="0"/>
+              </a:spcBef>
+              <a:spcAft>
+                <a:spcPts val="400"/>
+              </a:spcAft>
+              <a:buNone/>
+              <a:defRPr sz="1850" b="0">
+                <a:solidFill>
+                  <a:srgbClr val="303437"/>
+                </a:solidFill>
+                <a:latin typeface="Noto Sans"/>
+              </a:defRPr>
+            </a:pPr>
+            <a:r>
+              <a:rPr sz="1850" b="1" lang="ja-JP" altLang="en-US">
+                <a:solidFill>
+                  <a:srgbClr val="303437"/>
+                </a:solidFill>
+                <a:latin typeface="Noto Sans"/>
+                <a:ea typeface="Noto Sans CJK JP"/>
+                <a:cs typeface="Noto Sans"/>
+              </a:rPr>
+              <a:t>pet_bustm.py</a:t>
+            </a:r>
+          </a:p>
+          <a:p>
+            <a:pPr algn="l">
+              <a:lnSpc>
+                <a:spcPct val="114000"/>
+              </a:lnSpc>
+              <a:spcBef>
+                <a:spcPts val="0"/>
+              </a:spcBef>
+              <a:spcAft>
+                <a:spcPts val="500"/>
+              </a:spcAft>
+              <a:buNone/>
+              <a:defRPr sz="1250" b="0">
+                <a:solidFill>
+                  <a:srgbClr val="303437"/>
+                </a:solidFill>
+                <a:latin typeface="Noto Sans"/>
+              </a:defRPr>
+            </a:pPr>
+            <a:r>
+              <a:rPr sz="1250" b="0" lang="ja-JP" altLang="en-US">
+                <a:solidFill>
+                  <a:srgbClr val="626669"/>
+                </a:solidFill>
+                <a:latin typeface="Noto Sans"/>
+                <a:ea typeface="Noto Sans CJK JP"/>
+                <a:cs typeface="Noto Sans"/>
+              </a:rPr>
+              <a:t>CLUE team (n.d.). FewCLUE公式実装。参照2026-10-19。</a:t>
+            </a:r>
+          </a:p>
+          <a:p>
+            <a:pPr algn="l">
+              <a:lnSpc>
+                <a:spcPct val="114000"/>
+              </a:lnSpc>
+              <a:spcBef>
+                <a:spcPts val="0"/>
+              </a:spcBef>
+              <a:spcAft>
+                <a:spcPts val="400"/>
+              </a:spcAft>
+              <a:buNone/>
+              <a:defRPr sz="1750" b="0">
+                <a:solidFill>
+                  <a:srgbClr val="303437"/>
+                </a:solidFill>
+                <a:latin typeface="Noto Sans"/>
+              </a:defRPr>
+            </a:pPr>
+            <a:r>
+              <a:rPr sz="1750" b="0" lang="ja-JP" altLang="en-US">
+                <a:solidFill>
+                  <a:srgbClr val="303437"/>
+                </a:solidFill>
+                <a:latin typeface="Noto Sans"/>
+                <a:ea typeface="Noto Sans CJK JP"/>
+                <a:cs typeface="Noto Sans"/>
+              </a:rPr>
+              <a:t>発話対を穴埋め文に変え、「相」「不」のラベル語を予測する。学習・開発・公開テストの読込と採点を実装する。</a:t>
+            </a:r>
+          </a:p>
+          <a:p>
+            <a:pPr algn="l">
+              <a:lnSpc>
+                <a:spcPct val="114000"/>
+              </a:lnSpc>
+              <a:spcBef>
+                <a:spcPts val="0"/>
+              </a:spcBef>
+              <a:spcAft>
+                <a:spcPts val="0"/>
+              </a:spcAft>
+              <a:buNone/>
+              <a:defRPr sz="1050" b="0">
+                <a:solidFill>
+                  <a:srgbClr val="303437"/>
+                </a:solidFill>
+                <a:latin typeface="Noto Sans"/>
+              </a:defRPr>
+            </a:pPr>
+            <a:r>
+              <a:rPr sz="1050" b="0" lang="ja-JP" altLang="en-US">
+                <a:solidFill>
+                  <a:srgbClr val="626669"/>
+                </a:solidFill>
+                <a:latin typeface="Noto Sans"/>
+                <a:ea typeface="Noto Sans CJK JP"/>
+                <a:cs typeface="Noto Sans"/>
+                <a:hlinkClick r:id="rId2"/>
+              </a:rPr>
+              <a:t>https://github.com/CLUEbenchmark/FewCLUE/blob/main/baselines/models_keras/pet/pet_bustm.py</a:t>
+            </a:r>
+          </a:p>
+        </p:txBody>
+      </p:sp>
+    </p:spTree>
+  </p:cSld>
+  <p:clrMapOvr>
+    <a:masterClrMapping/>
+  </p:clrMapOvr>
+</p:sld>
+</file>
+
 <file path=ppt/slides/slide5.xml><?xml version="1.0" encoding="utf-8"?>
 <p:sld xmlns:a="http://schemas.openxmlformats.org/drawingml/2006/main" xmlns:p="http://schemas.openxmlformats.org/presentationml/2006/main" xmlns:r="http://schemas.openxmlformats.org/officeDocument/2006/relationships">
   <p:cSld>
@@ -24682,1612 +25510,6 @@
                 <a:hlinkClick r:id="rId2"/>
               </a:rPr>
               <a:t>https://github.com/xiaobu-coai/BUSTM</a:t>
-            </a:r>
-          </a:p>
-        </p:txBody>
-      </p:sp>
-    </p:spTree>
-  </p:cSld>
-  <p:clrMapOvr>
-    <a:masterClrMapping/>
-  </p:clrMapOvr>
-</p:sld>
-</file>
-
-<file path=ppt/slides/slide50.xml><?xml version="1.0" encoding="utf-8"?>
-<p:sld xmlns:a="http://schemas.openxmlformats.org/drawingml/2006/main" xmlns:p="http://schemas.openxmlformats.org/presentationml/2006/main" xmlns:r="http://schemas.openxmlformats.org/officeDocument/2006/relationships">
-  <p:cSld>
-    <p:spTree>
-      <p:nvGrpSpPr>
-        <p:cNvPr id="1" name=""/>
-        <p:cNvGrpSpPr/>
-        <p:nvPr/>
-      </p:nvGrpSpPr>
-      <p:grpSpPr/>
-      <p:sp>
-        <p:nvSpPr>
-          <p:cNvPr id="2" name="Title 1"/>
-          <p:cNvSpPr>
-            <a:spLocks noGrp="1"/>
-          </p:cNvSpPr>
-          <p:nvPr>
-            <p:ph type="title"/>
-          </p:nvPr>
-        </p:nvSpPr>
-        <p:spPr>
-          <a:xfrm>
-            <a:off x="548640" y="2506875"/>
-            <a:ext cx="8046720" cy="585216"/>
-          </a:xfrm>
-        </p:spPr>
-        <p:txBody>
-          <a:bodyPr wrap="square" lIns="0" rIns="0" tIns="0" bIns="0" anchor="ctr">
-            <a:noAutofit/>
-          </a:bodyPr>
-          <a:lstStyle/>
-          <a:p>
-            <a:pPr algn="ctr">
-              <a:lnSpc>
-                <a:spcPct val="110000"/>
-              </a:lnSpc>
-              <a:buNone/>
-              <a:defRPr sz="3600" b="0">
-                <a:solidFill>
-                  <a:srgbClr val="303437"/>
-                </a:solidFill>
-                <a:latin typeface="Noto Sans"/>
-              </a:defRPr>
-            </a:pPr>
-            <a:r>
-              <a:rPr sz="3600" b="1" lang="ja-JP" altLang="en-US">
-                <a:solidFill>
-                  <a:srgbClr val="303437"/>
-                </a:solidFill>
-                <a:latin typeface="Noto Sans"/>
-                <a:ea typeface="Noto Sans CJK JP"/>
-                <a:cs typeface="Noto Sans"/>
-              </a:rPr>
-              <a:t>参考文献</a:t>
-            </a:r>
-          </a:p>
-        </p:txBody>
-      </p:sp>
-      <p:sp>
-        <p:nvSpPr>
-          <p:cNvPr id="3" name="Title 2"/>
-          <p:cNvSpPr>
-            <a:spLocks noGrp="1"/>
-          </p:cNvSpPr>
-          <p:nvPr>
-            <p:ph type="title" idx="2"/>
-          </p:nvPr>
-        </p:nvSpPr>
-        <p:spPr>
-          <a:xfrm>
-            <a:off x="75895" y="0"/>
-            <a:ext cx="8115300" cy="480060"/>
-          </a:xfrm>
-        </p:spPr>
-        <p:txBody>
-          <a:bodyPr wrap="square" lIns="0" rIns="0" tIns="0" bIns="0" anchor="ctr">
-            <a:noAutofit/>
-          </a:bodyPr>
-          <a:lstStyle/>
-          <a:p>
-            <a:pPr algn="l">
-              <a:lnSpc>
-                <a:spcPct val="110000"/>
-              </a:lnSpc>
-              <a:buNone/>
-              <a:defRPr sz="1400" b="0">
-                <a:solidFill>
-                  <a:srgbClr val="303437"/>
-                </a:solidFill>
-                <a:latin typeface="Noto Sans"/>
-              </a:defRPr>
-            </a:pPr>
-            <a:r>
-              <a:rPr sz="1400" b="1" lang="ja-JP" altLang="en-US">
-                <a:solidFill>
-                  <a:srgbClr val="FFFEF8"/>
-                </a:solidFill>
-                <a:latin typeface="Noto Sans"/>
-                <a:ea typeface="Noto Sans CJK JP"/>
-                <a:cs typeface="Noto Sans"/>
-              </a:rPr>
-              <a:t>Appendix: 3. 参考文献</a:t>
-            </a:r>
-          </a:p>
-        </p:txBody>
-      </p:sp>
-    </p:spTree>
-  </p:cSld>
-  <p:clrMapOvr>
-    <a:masterClrMapping/>
-  </p:clrMapOvr>
-</p:sld>
-</file>
-
-<file path=ppt/slides/slide51.xml><?xml version="1.0" encoding="utf-8"?>
-<p:sld xmlns:a="http://schemas.openxmlformats.org/drawingml/2006/main" xmlns:p="http://schemas.openxmlformats.org/presentationml/2006/main" xmlns:r="http://schemas.openxmlformats.org/officeDocument/2006/relationships">
-  <p:cSld>
-    <p:spTree>
-      <p:nvGrpSpPr>
-        <p:cNvPr id="1" name=""/>
-        <p:cNvGrpSpPr/>
-        <p:nvPr/>
-      </p:nvGrpSpPr>
-      <p:grpSpPr/>
-      <p:sp>
-        <p:nvSpPr>
-          <p:cNvPr id="2" name="Title 1"/>
-          <p:cNvSpPr>
-            <a:spLocks noGrp="1"/>
-          </p:cNvSpPr>
-          <p:nvPr>
-            <p:ph type="title"/>
-          </p:nvPr>
-        </p:nvSpPr>
-        <p:spPr>
-          <a:xfrm>
-            <a:off x="468172" y="650138"/>
-            <a:ext cx="8206740" cy="616305"/>
-          </a:xfrm>
-        </p:spPr>
-        <p:txBody>
-          <a:bodyPr wrap="square" lIns="0" rIns="0" tIns="0" bIns="0">
-            <a:noAutofit/>
-          </a:bodyPr>
-          <a:lstStyle/>
-          <a:p>
-            <a:pPr algn="l">
-              <a:lnSpc>
-                <a:spcPct val="110000"/>
-              </a:lnSpc>
-              <a:buNone/>
-              <a:defRPr sz="2800" b="0">
-                <a:solidFill>
-                  <a:srgbClr val="303437"/>
-                </a:solidFill>
-                <a:latin typeface="Noto Sans"/>
-              </a:defRPr>
-            </a:pPr>
-            <a:r>
-              <a:rPr sz="2800" b="1" lang="ja-JP" altLang="en-US">
-                <a:solidFill>
-                  <a:srgbClr val="303437"/>
-                </a:solidFill>
-                <a:latin typeface="Noto Sans"/>
-                <a:ea typeface="Noto Sans CJK JP"/>
-                <a:cs typeface="Noto Sans"/>
-              </a:rPr>
-              <a:t>参考文献</a:t>
-            </a:r>
-          </a:p>
-        </p:txBody>
-      </p:sp>
-      <p:sp>
-        <p:nvSpPr>
-          <p:cNvPr id="3" name="Title 2"/>
-          <p:cNvSpPr>
-            <a:spLocks noGrp="1"/>
-          </p:cNvSpPr>
-          <p:nvPr>
-            <p:ph type="title" idx="2"/>
-          </p:nvPr>
-        </p:nvSpPr>
-        <p:spPr>
-          <a:xfrm>
-            <a:off x="75895" y="0"/>
-            <a:ext cx="8115300" cy="480060"/>
-          </a:xfrm>
-        </p:spPr>
-        <p:txBody>
-          <a:bodyPr wrap="square" lIns="0" rIns="0" tIns="0" bIns="0" anchor="ctr">
-            <a:noAutofit/>
-          </a:bodyPr>
-          <a:lstStyle/>
-          <a:p>
-            <a:pPr algn="l">
-              <a:lnSpc>
-                <a:spcPct val="110000"/>
-              </a:lnSpc>
-              <a:buNone/>
-              <a:defRPr sz="1400" b="0">
-                <a:solidFill>
-                  <a:srgbClr val="303437"/>
-                </a:solidFill>
-                <a:latin typeface="Noto Sans"/>
-              </a:defRPr>
-            </a:pPr>
-            <a:r>
-              <a:rPr sz="1400" b="1" lang="ja-JP" altLang="en-US">
-                <a:solidFill>
-                  <a:srgbClr val="FFFEF8"/>
-                </a:solidFill>
-                <a:latin typeface="Noto Sans"/>
-                <a:ea typeface="Noto Sans CJK JP"/>
-                <a:cs typeface="Noto Sans"/>
-              </a:rPr>
-              <a:t>Appendix: 3. 参考文献</a:t>
-            </a:r>
-          </a:p>
-        </p:txBody>
-      </p:sp>
-      <p:sp>
-        <p:nvSpPr>
-          <p:cNvPr id="4" name="文献 1: BUSTM: OPPO XiaoBu Dialogue Short Text Matching Dataset"/>
-          <p:cNvSpPr txBox="1"/>
-          <p:nvPr/>
-        </p:nvSpPr>
-        <p:spPr>
-          <a:xfrm>
-            <a:off x="548640" y="1463040"/>
-            <a:ext cx="8046720" cy="1574419"/>
-          </a:xfrm>
-          <a:prstGeom prst="rect">
-            <a:avLst/>
-          </a:prstGeom>
-          <a:noFill/>
-        </p:spPr>
-        <p:txBody>
-          <a:bodyPr wrap="square" lIns="0" rIns="0" tIns="0" bIns="0">
-            <a:noAutofit/>
-          </a:bodyPr>
-          <a:lstStyle/>
-          <a:p>
-            <a:pPr algn="l">
-              <a:lnSpc>
-                <a:spcPct val="114000"/>
-              </a:lnSpc>
-              <a:spcBef>
-                <a:spcPts val="0"/>
-              </a:spcBef>
-              <a:spcAft>
-                <a:spcPts val="400"/>
-              </a:spcAft>
-              <a:buNone/>
-              <a:defRPr sz="1850" b="0">
-                <a:solidFill>
-                  <a:srgbClr val="303437"/>
-                </a:solidFill>
-                <a:latin typeface="Noto Sans"/>
-              </a:defRPr>
-            </a:pPr>
-            <a:r>
-              <a:rPr sz="1850" b="1" lang="ja-JP" altLang="en-US">
-                <a:solidFill>
-                  <a:srgbClr val="303437"/>
-                </a:solidFill>
-                <a:latin typeface="Noto Sans"/>
-                <a:ea typeface="Noto Sans CJK JP"/>
-                <a:cs typeface="Noto Sans"/>
-              </a:rPr>
-              <a:t>BUSTM: OPPO XiaoBu Dialogue Short Text Matching Dataset</a:t>
-            </a:r>
-          </a:p>
-          <a:p>
-            <a:pPr algn="l">
-              <a:lnSpc>
-                <a:spcPct val="114000"/>
-              </a:lnSpc>
-              <a:spcBef>
-                <a:spcPts val="0"/>
-              </a:spcBef>
-              <a:spcAft>
-                <a:spcPts val="500"/>
-              </a:spcAft>
-              <a:buNone/>
-              <a:defRPr sz="1250" b="0">
-                <a:solidFill>
-                  <a:srgbClr val="303437"/>
-                </a:solidFill>
-                <a:latin typeface="Noto Sans"/>
-              </a:defRPr>
-            </a:pPr>
-            <a:r>
-              <a:rPr sz="1250" b="0" lang="ja-JP" altLang="en-US">
-                <a:solidFill>
-                  <a:srgbClr val="626669"/>
-                </a:solidFill>
-                <a:latin typeface="Noto Sans"/>
-                <a:ea typeface="Noto Sans CJK JP"/>
-                <a:cs typeface="Noto Sans"/>
-              </a:rPr>
-              <a:t>OPPO XiaoBu Conversational-AI Center · 2021 · 公式公開</a:t>
-            </a:r>
-          </a:p>
-          <a:p>
-            <a:pPr algn="l">
-              <a:lnSpc>
-                <a:spcPct val="114000"/>
-              </a:lnSpc>
-              <a:spcBef>
-                <a:spcPts val="0"/>
-              </a:spcBef>
-              <a:spcAft>
-                <a:spcPts val="400"/>
-              </a:spcAft>
-              <a:buNone/>
-              <a:defRPr sz="1750" b="0">
-                <a:solidFill>
-                  <a:srgbClr val="303437"/>
-                </a:solidFill>
-                <a:latin typeface="Noto Sans"/>
-              </a:defRPr>
-            </a:pPr>
-            <a:r>
-              <a:rPr sz="1750" b="0" lang="ja-JP" altLang="en-US">
-                <a:solidFill>
-                  <a:srgbClr val="303437"/>
-                </a:solidFill>
-                <a:latin typeface="Noto Sans"/>
-                <a:ea typeface="Noto Sans CJK JP"/>
-                <a:cs typeface="Noto Sans"/>
-              </a:rPr>
-              <a:t>スマートフォンとIoT機器向けアシスタントの短文意味照合データ。FewCLUE配布へのリンクと引用方法を示す。</a:t>
-            </a:r>
-          </a:p>
-          <a:p>
-            <a:pPr algn="l">
-              <a:lnSpc>
-                <a:spcPct val="114000"/>
-              </a:lnSpc>
-              <a:spcBef>
-                <a:spcPts val="0"/>
-              </a:spcBef>
-              <a:spcAft>
-                <a:spcPts val="0"/>
-              </a:spcAft>
-              <a:buNone/>
-              <a:defRPr sz="1050" b="0">
-                <a:solidFill>
-                  <a:srgbClr val="303437"/>
-                </a:solidFill>
-                <a:latin typeface="Noto Sans"/>
-              </a:defRPr>
-            </a:pPr>
-            <a:r>
-              <a:rPr sz="1050" b="0" lang="ja-JP" altLang="en-US">
-                <a:solidFill>
-                  <a:srgbClr val="626669"/>
-                </a:solidFill>
-                <a:latin typeface="Noto Sans"/>
-                <a:ea typeface="Noto Sans CJK JP"/>
-                <a:cs typeface="Noto Sans"/>
-                <a:hlinkClick r:id="rId2"/>
-              </a:rPr>
-              <a:t>https://github.com/xiaobu-coai/BUSTM</a:t>
-            </a:r>
-          </a:p>
-        </p:txBody>
-      </p:sp>
-      <p:sp>
-        <p:nvSpPr>
-          <p:cNvPr id="5" name="文献 2: FewCLUE: A Chinese Few-shot Learning Evaluation Benchmark"/>
-          <p:cNvSpPr txBox="1"/>
-          <p:nvPr/>
-        </p:nvSpPr>
-        <p:spPr>
-          <a:xfrm>
-            <a:off x="548640" y="3040507"/>
-            <a:ext cx="8046720" cy="1755394"/>
-          </a:xfrm>
-          <a:prstGeom prst="rect">
-            <a:avLst/>
-          </a:prstGeom>
-          <a:noFill/>
-        </p:spPr>
-        <p:txBody>
-          <a:bodyPr wrap="square" lIns="0" rIns="0" tIns="0" bIns="0">
-            <a:noAutofit/>
-          </a:bodyPr>
-          <a:lstStyle/>
-          <a:p>
-            <a:pPr algn="l">
-              <a:lnSpc>
-                <a:spcPct val="114000"/>
-              </a:lnSpc>
-              <a:spcBef>
-                <a:spcPts val="0"/>
-              </a:spcBef>
-              <a:spcAft>
-                <a:spcPts val="400"/>
-              </a:spcAft>
-              <a:buNone/>
-              <a:defRPr sz="1850" b="0">
-                <a:solidFill>
-                  <a:srgbClr val="303437"/>
-                </a:solidFill>
-                <a:latin typeface="Noto Sans"/>
-              </a:defRPr>
-            </a:pPr>
-            <a:r>
-              <a:rPr sz="1850" b="1" lang="ja-JP" altLang="en-US">
-                <a:solidFill>
-                  <a:srgbClr val="303437"/>
-                </a:solidFill>
-                <a:latin typeface="Noto Sans"/>
-                <a:ea typeface="Noto Sans CJK JP"/>
-                <a:cs typeface="Noto Sans"/>
-              </a:rPr>
-              <a:t>FewCLUE: A Chinese Few-shot Learning Evaluation Benchmark</a:t>
-            </a:r>
-          </a:p>
-          <a:p>
-            <a:pPr algn="l">
-              <a:lnSpc>
-                <a:spcPct val="114000"/>
-              </a:lnSpc>
-              <a:spcBef>
-                <a:spcPts val="0"/>
-              </a:spcBef>
-              <a:spcAft>
-                <a:spcPts val="500"/>
-              </a:spcAft>
-              <a:buNone/>
-              <a:defRPr sz="1250" b="0">
-                <a:solidFill>
-                  <a:srgbClr val="303437"/>
-                </a:solidFill>
-                <a:latin typeface="Noto Sans"/>
-              </a:defRPr>
-            </a:pPr>
-            <a:r>
-              <a:rPr sz="1250" b="0" lang="ja-JP" altLang="en-US">
-                <a:solidFill>
-                  <a:srgbClr val="626669"/>
-                </a:solidFill>
-                <a:latin typeface="Noto Sans"/>
-                <a:ea typeface="Noto Sans CJK JP"/>
-                <a:cs typeface="Noto Sans"/>
-              </a:rPr>
-              <a:t>Liang Xu, Xiaojing Lu, Chenyang Yuan, Xuanwei Zhang, Huilin Xu, Hu Yuan, Guoao Wei, Xiang Pan, Xin Tian, Libo Qin, Hai Hu · 2021 · arXiv:2107.07498v2</a:t>
-            </a:r>
-          </a:p>
-          <a:p>
-            <a:pPr algn="l">
-              <a:lnSpc>
-                <a:spcPct val="114000"/>
-              </a:lnSpc>
-              <a:spcBef>
-                <a:spcPts val="0"/>
-              </a:spcBef>
-              <a:spcAft>
-                <a:spcPts val="400"/>
-              </a:spcAft>
-              <a:buNone/>
-              <a:defRPr sz="1750" b="0">
-                <a:solidFill>
-                  <a:srgbClr val="303437"/>
-                </a:solidFill>
-                <a:latin typeface="Noto Sans"/>
-              </a:defRPr>
-            </a:pPr>
-            <a:r>
-              <a:rPr sz="1750" b="0" lang="ja-JP" altLang="en-US">
-                <a:solidFill>
-                  <a:srgbClr val="303437"/>
-                </a:solidFill>
-                <a:latin typeface="Noto Sans"/>
-                <a:ea typeface="Noto Sans CJK JP"/>
-                <a:cs typeface="Noto Sans"/>
-              </a:rPr>
-              <a:t>中国語の九つの少数例学習課題と、直接微調整・穴埋め形式・含意判定などの比較を報告する。</a:t>
-            </a:r>
-          </a:p>
-          <a:p>
-            <a:pPr algn="l">
-              <a:lnSpc>
-                <a:spcPct val="114000"/>
-              </a:lnSpc>
-              <a:spcBef>
-                <a:spcPts val="0"/>
-              </a:spcBef>
-              <a:spcAft>
-                <a:spcPts val="0"/>
-              </a:spcAft>
-              <a:buNone/>
-              <a:defRPr sz="1050" b="0">
-                <a:solidFill>
-                  <a:srgbClr val="303437"/>
-                </a:solidFill>
-                <a:latin typeface="Noto Sans"/>
-              </a:defRPr>
-            </a:pPr>
-            <a:r>
-              <a:rPr sz="1050" b="0" lang="ja-JP" altLang="en-US">
-                <a:solidFill>
-                  <a:srgbClr val="626669"/>
-                </a:solidFill>
-                <a:latin typeface="Noto Sans"/>
-                <a:ea typeface="Noto Sans CJK JP"/>
-                <a:cs typeface="Noto Sans"/>
-                <a:hlinkClick r:id="rId3"/>
-              </a:rPr>
-              <a:t>https://arxiv.org/abs/2107.07498</a:t>
-            </a:r>
-          </a:p>
-        </p:txBody>
-      </p:sp>
-    </p:spTree>
-  </p:cSld>
-  <p:clrMapOvr>
-    <a:masterClrMapping/>
-  </p:clrMapOvr>
-</p:sld>
-</file>
-
-<file path=ppt/slides/slide52.xml><?xml version="1.0" encoding="utf-8"?>
-<p:sld xmlns:a="http://schemas.openxmlformats.org/drawingml/2006/main" xmlns:p="http://schemas.openxmlformats.org/presentationml/2006/main" xmlns:r="http://schemas.openxmlformats.org/officeDocument/2006/relationships">
-  <p:cSld>
-    <p:spTree>
-      <p:nvGrpSpPr>
-        <p:cNvPr id="1" name=""/>
-        <p:cNvGrpSpPr/>
-        <p:nvPr/>
-      </p:nvGrpSpPr>
-      <p:grpSpPr/>
-      <p:sp>
-        <p:nvSpPr>
-          <p:cNvPr id="2" name="Title 1"/>
-          <p:cNvSpPr>
-            <a:spLocks noGrp="1"/>
-          </p:cNvSpPr>
-          <p:nvPr>
-            <p:ph type="title"/>
-          </p:nvPr>
-        </p:nvSpPr>
-        <p:spPr>
-          <a:xfrm>
-            <a:off x="468172" y="650138"/>
-            <a:ext cx="8206740" cy="616305"/>
-          </a:xfrm>
-        </p:spPr>
-        <p:txBody>
-          <a:bodyPr wrap="square" lIns="0" rIns="0" tIns="0" bIns="0">
-            <a:noAutofit/>
-          </a:bodyPr>
-          <a:lstStyle/>
-          <a:p>
-            <a:pPr algn="l">
-              <a:lnSpc>
-                <a:spcPct val="110000"/>
-              </a:lnSpc>
-              <a:buNone/>
-              <a:defRPr sz="2800" b="0">
-                <a:solidFill>
-                  <a:srgbClr val="303437"/>
-                </a:solidFill>
-                <a:latin typeface="Noto Sans"/>
-              </a:defRPr>
-            </a:pPr>
-            <a:r>
-              <a:rPr sz="2800" b="1" lang="ja-JP" altLang="en-US">
-                <a:solidFill>
-                  <a:srgbClr val="303437"/>
-                </a:solidFill>
-                <a:latin typeface="Noto Sans"/>
-                <a:ea typeface="Noto Sans CJK JP"/>
-                <a:cs typeface="Noto Sans"/>
-              </a:rPr>
-              <a:t>参考文献</a:t>
-            </a:r>
-          </a:p>
-        </p:txBody>
-      </p:sp>
-      <p:sp>
-        <p:nvSpPr>
-          <p:cNvPr id="3" name="Title 2"/>
-          <p:cNvSpPr>
-            <a:spLocks noGrp="1"/>
-          </p:cNvSpPr>
-          <p:nvPr>
-            <p:ph type="title" idx="2"/>
-          </p:nvPr>
-        </p:nvSpPr>
-        <p:spPr>
-          <a:xfrm>
-            <a:off x="75895" y="0"/>
-            <a:ext cx="8115300" cy="480060"/>
-          </a:xfrm>
-        </p:spPr>
-        <p:txBody>
-          <a:bodyPr wrap="square" lIns="0" rIns="0" tIns="0" bIns="0" anchor="ctr">
-            <a:noAutofit/>
-          </a:bodyPr>
-          <a:lstStyle/>
-          <a:p>
-            <a:pPr algn="l">
-              <a:lnSpc>
-                <a:spcPct val="110000"/>
-              </a:lnSpc>
-              <a:buNone/>
-              <a:defRPr sz="1400" b="0">
-                <a:solidFill>
-                  <a:srgbClr val="303437"/>
-                </a:solidFill>
-                <a:latin typeface="Noto Sans"/>
-              </a:defRPr>
-            </a:pPr>
-            <a:r>
-              <a:rPr sz="1400" b="1" lang="ja-JP" altLang="en-US">
-                <a:solidFill>
-                  <a:srgbClr val="FFFEF8"/>
-                </a:solidFill>
-                <a:latin typeface="Noto Sans"/>
-                <a:ea typeface="Noto Sans CJK JP"/>
-                <a:cs typeface="Noto Sans"/>
-              </a:rPr>
-              <a:t>Appendix: 3. 参考文献</a:t>
-            </a:r>
-          </a:p>
-        </p:txBody>
-      </p:sp>
-      <p:sp>
-        <p:nvSpPr>
-          <p:cNvPr id="4" name="文献 1: FewCLUE — Official Dataset Distribution"/>
-          <p:cNvSpPr txBox="1"/>
-          <p:nvPr/>
-        </p:nvSpPr>
-        <p:spPr>
-          <a:xfrm>
-            <a:off x="548640" y="1463040"/>
-            <a:ext cx="8046720" cy="1574419"/>
-          </a:xfrm>
-          <a:prstGeom prst="rect">
-            <a:avLst/>
-          </a:prstGeom>
-          <a:noFill/>
-        </p:spPr>
-        <p:txBody>
-          <a:bodyPr wrap="square" lIns="0" rIns="0" tIns="0" bIns="0">
-            <a:noAutofit/>
-          </a:bodyPr>
-          <a:lstStyle/>
-          <a:p>
-            <a:pPr algn="l">
-              <a:lnSpc>
-                <a:spcPct val="114000"/>
-              </a:lnSpc>
-              <a:spcBef>
-                <a:spcPts val="0"/>
-              </a:spcBef>
-              <a:spcAft>
-                <a:spcPts val="400"/>
-              </a:spcAft>
-              <a:buNone/>
-              <a:defRPr sz="1850" b="0">
-                <a:solidFill>
-                  <a:srgbClr val="303437"/>
-                </a:solidFill>
-                <a:latin typeface="Noto Sans"/>
-              </a:defRPr>
-            </a:pPr>
-            <a:r>
-              <a:rPr sz="1850" b="1" lang="ja-JP" altLang="en-US">
-                <a:solidFill>
-                  <a:srgbClr val="303437"/>
-                </a:solidFill>
-                <a:latin typeface="Noto Sans"/>
-                <a:ea typeface="Noto Sans CJK JP"/>
-                <a:cs typeface="Noto Sans"/>
-              </a:rPr>
-              <a:t>FewCLUE — Official Dataset Distribution</a:t>
-            </a:r>
-          </a:p>
-          <a:p>
-            <a:pPr algn="l">
-              <a:lnSpc>
-                <a:spcPct val="114000"/>
-              </a:lnSpc>
-              <a:spcBef>
-                <a:spcPts val="0"/>
-              </a:spcBef>
-              <a:spcAft>
-                <a:spcPts val="500"/>
-              </a:spcAft>
-              <a:buNone/>
-              <a:defRPr sz="1250" b="0">
-                <a:solidFill>
-                  <a:srgbClr val="303437"/>
-                </a:solidFill>
-                <a:latin typeface="Noto Sans"/>
-              </a:defRPr>
-            </a:pPr>
-            <a:r>
-              <a:rPr sz="1250" b="0" lang="ja-JP" altLang="en-US">
-                <a:solidFill>
-                  <a:srgbClr val="626669"/>
-                </a:solidFill>
-                <a:latin typeface="Noto Sans"/>
-                <a:ea typeface="Noto Sans CJK JP"/>
-                <a:cs typeface="Noto Sans"/>
-              </a:rPr>
-              <a:t>CLUE team · 2021 · 公式配布</a:t>
-            </a:r>
-          </a:p>
-          <a:p>
-            <a:pPr algn="l">
-              <a:lnSpc>
-                <a:spcPct val="114000"/>
-              </a:lnSpc>
-              <a:spcBef>
-                <a:spcPts val="0"/>
-              </a:spcBef>
-              <a:spcAft>
-                <a:spcPts val="400"/>
-              </a:spcAft>
-              <a:buNone/>
-              <a:defRPr sz="1750" b="0">
-                <a:solidFill>
-                  <a:srgbClr val="303437"/>
-                </a:solidFill>
-                <a:latin typeface="Noto Sans"/>
-              </a:defRPr>
-            </a:pPr>
-            <a:r>
-              <a:rPr sz="1750" b="0" lang="ja-JP" altLang="en-US">
-                <a:solidFill>
-                  <a:srgbClr val="303437"/>
-                </a:solidFill>
-                <a:latin typeface="Noto Sans"/>
-                <a:ea typeface="Noto Sans CJK JP"/>
-                <a:cs typeface="Noto Sans"/>
-              </a:rPr>
-              <a:t>32件ずつの学習・開発組、公開正解付きテスト、提出用入力、未ラベル対をJSONL形式で公開する。</a:t>
-            </a:r>
-          </a:p>
-          <a:p>
-            <a:pPr algn="l">
-              <a:lnSpc>
-                <a:spcPct val="114000"/>
-              </a:lnSpc>
-              <a:spcBef>
-                <a:spcPts val="0"/>
-              </a:spcBef>
-              <a:spcAft>
-                <a:spcPts val="0"/>
-              </a:spcAft>
-              <a:buNone/>
-              <a:defRPr sz="1050" b="0">
-                <a:solidFill>
-                  <a:srgbClr val="303437"/>
-                </a:solidFill>
-                <a:latin typeface="Noto Sans"/>
-              </a:defRPr>
-            </a:pPr>
-            <a:r>
-              <a:rPr sz="1050" b="0" lang="ja-JP" altLang="en-US">
-                <a:solidFill>
-                  <a:srgbClr val="626669"/>
-                </a:solidFill>
-                <a:latin typeface="Noto Sans"/>
-                <a:ea typeface="Noto Sans CJK JP"/>
-                <a:cs typeface="Noto Sans"/>
-                <a:hlinkClick r:id="rId2"/>
-              </a:rPr>
-              <a:t>https://github.com/CLUEbenchmark/FewCLUE/tree/main/datasets/bustm</a:t>
-            </a:r>
-          </a:p>
-        </p:txBody>
-      </p:sp>
-      <p:sp>
-        <p:nvSpPr>
-          <p:cNvPr id="5" name="文献 2: FewCLUE — README and Evaluation Protocol"/>
-          <p:cNvSpPr txBox="1"/>
-          <p:nvPr/>
-        </p:nvSpPr>
-        <p:spPr>
-          <a:xfrm>
-            <a:off x="548640" y="3040507"/>
-            <a:ext cx="8046720" cy="1574419"/>
-          </a:xfrm>
-          <a:prstGeom prst="rect">
-            <a:avLst/>
-          </a:prstGeom>
-          <a:noFill/>
-        </p:spPr>
-        <p:txBody>
-          <a:bodyPr wrap="square" lIns="0" rIns="0" tIns="0" bIns="0">
-            <a:noAutofit/>
-          </a:bodyPr>
-          <a:lstStyle/>
-          <a:p>
-            <a:pPr algn="l">
-              <a:lnSpc>
-                <a:spcPct val="114000"/>
-              </a:lnSpc>
-              <a:spcBef>
-                <a:spcPts val="0"/>
-              </a:spcBef>
-              <a:spcAft>
-                <a:spcPts val="400"/>
-              </a:spcAft>
-              <a:buNone/>
-              <a:defRPr sz="1850" b="0">
-                <a:solidFill>
-                  <a:srgbClr val="303437"/>
-                </a:solidFill>
-                <a:latin typeface="Noto Sans"/>
-              </a:defRPr>
-            </a:pPr>
-            <a:r>
-              <a:rPr sz="1850" b="1" lang="ja-JP" altLang="en-US">
-                <a:solidFill>
-                  <a:srgbClr val="303437"/>
-                </a:solidFill>
-                <a:latin typeface="Noto Sans"/>
-                <a:ea typeface="Noto Sans CJK JP"/>
-                <a:cs typeface="Noto Sans"/>
-              </a:rPr>
-              <a:t>FewCLUE — README and Evaluation Protocol</a:t>
-            </a:r>
-          </a:p>
-          <a:p>
-            <a:pPr algn="l">
-              <a:lnSpc>
-                <a:spcPct val="114000"/>
-              </a:lnSpc>
-              <a:spcBef>
-                <a:spcPts val="0"/>
-              </a:spcBef>
-              <a:spcAft>
-                <a:spcPts val="500"/>
-              </a:spcAft>
-              <a:buNone/>
-              <a:defRPr sz="1250" b="0">
-                <a:solidFill>
-                  <a:srgbClr val="303437"/>
-                </a:solidFill>
-                <a:latin typeface="Noto Sans"/>
-              </a:defRPr>
-            </a:pPr>
-            <a:r>
-              <a:rPr sz="1250" b="0" lang="ja-JP" altLang="en-US">
-                <a:solidFill>
-                  <a:srgbClr val="626669"/>
-                </a:solidFill>
-                <a:latin typeface="Noto Sans"/>
-                <a:ea typeface="Noto Sans CJK JP"/>
-                <a:cs typeface="Noto Sans"/>
-              </a:rPr>
-              <a:t>CLUE team · 2021年の実験・コンテスト条件</a:t>
-            </a:r>
-          </a:p>
-          <a:p>
-            <a:pPr algn="l">
-              <a:lnSpc>
-                <a:spcPct val="114000"/>
-              </a:lnSpc>
-              <a:spcBef>
-                <a:spcPts val="0"/>
-              </a:spcBef>
-              <a:spcAft>
-                <a:spcPts val="400"/>
-              </a:spcAft>
-              <a:buNone/>
-              <a:defRPr sz="1750" b="0">
-                <a:solidFill>
-                  <a:srgbClr val="303437"/>
-                </a:solidFill>
-                <a:latin typeface="Noto Sans"/>
-              </a:defRPr>
-            </a:pPr>
-            <a:r>
-              <a:rPr sz="1750" b="0" lang="ja-JP" altLang="en-US">
-                <a:solidFill>
-                  <a:srgbClr val="303437"/>
-                </a:solidFill>
-                <a:latin typeface="Noto Sans"/>
-                <a:ea typeface="Noto Sans CJK JP"/>
-                <a:cs typeface="Noto Sans"/>
-              </a:rPr>
-              <a:t>公開テストと提出用テストの役割、複数学習条件の提出、人間評価とモデル比較、ライセンス欄を示す。</a:t>
-            </a:r>
-          </a:p>
-          <a:p>
-            <a:pPr algn="l">
-              <a:lnSpc>
-                <a:spcPct val="114000"/>
-              </a:lnSpc>
-              <a:spcBef>
-                <a:spcPts val="0"/>
-              </a:spcBef>
-              <a:spcAft>
-                <a:spcPts val="0"/>
-              </a:spcAft>
-              <a:buNone/>
-              <a:defRPr sz="1050" b="0">
-                <a:solidFill>
-                  <a:srgbClr val="303437"/>
-                </a:solidFill>
-                <a:latin typeface="Noto Sans"/>
-              </a:defRPr>
-            </a:pPr>
-            <a:r>
-              <a:rPr sz="1050" b="0" lang="ja-JP" altLang="en-US">
-                <a:solidFill>
-                  <a:srgbClr val="626669"/>
-                </a:solidFill>
-                <a:latin typeface="Noto Sans"/>
-                <a:ea typeface="Noto Sans CJK JP"/>
-                <a:cs typeface="Noto Sans"/>
-                <a:hlinkClick r:id="rId3"/>
-              </a:rPr>
-              <a:t>https://github.com/CLUEbenchmark/FewCLUE/blob/main/README.md</a:t>
-            </a:r>
-          </a:p>
-        </p:txBody>
-      </p:sp>
-    </p:spTree>
-  </p:cSld>
-  <p:clrMapOvr>
-    <a:masterClrMapping/>
-  </p:clrMapOvr>
-</p:sld>
-</file>
-
-<file path=ppt/slides/slide53.xml><?xml version="1.0" encoding="utf-8"?>
-<p:sld xmlns:a="http://schemas.openxmlformats.org/drawingml/2006/main" xmlns:p="http://schemas.openxmlformats.org/presentationml/2006/main" xmlns:r="http://schemas.openxmlformats.org/officeDocument/2006/relationships">
-  <p:cSld>
-    <p:spTree>
-      <p:nvGrpSpPr>
-        <p:cNvPr id="1" name=""/>
-        <p:cNvGrpSpPr/>
-        <p:nvPr/>
-      </p:nvGrpSpPr>
-      <p:grpSpPr/>
-      <p:sp>
-        <p:nvSpPr>
-          <p:cNvPr id="2" name="Title 1"/>
-          <p:cNvSpPr>
-            <a:spLocks noGrp="1"/>
-          </p:cNvSpPr>
-          <p:nvPr>
-            <p:ph type="title"/>
-          </p:nvPr>
-        </p:nvSpPr>
-        <p:spPr>
-          <a:xfrm>
-            <a:off x="468172" y="650138"/>
-            <a:ext cx="8206740" cy="616305"/>
-          </a:xfrm>
-        </p:spPr>
-        <p:txBody>
-          <a:bodyPr wrap="square" lIns="0" rIns="0" tIns="0" bIns="0">
-            <a:noAutofit/>
-          </a:bodyPr>
-          <a:lstStyle/>
-          <a:p>
-            <a:pPr algn="l">
-              <a:lnSpc>
-                <a:spcPct val="110000"/>
-              </a:lnSpc>
-              <a:buNone/>
-              <a:defRPr sz="2800" b="0">
-                <a:solidFill>
-                  <a:srgbClr val="303437"/>
-                </a:solidFill>
-                <a:latin typeface="Noto Sans"/>
-              </a:defRPr>
-            </a:pPr>
-            <a:r>
-              <a:rPr sz="2800" b="1" lang="ja-JP" altLang="en-US">
-                <a:solidFill>
-                  <a:srgbClr val="303437"/>
-                </a:solidFill>
-                <a:latin typeface="Noto Sans"/>
-                <a:ea typeface="Noto Sans CJK JP"/>
-                <a:cs typeface="Noto Sans"/>
-              </a:rPr>
-              <a:t>参考文献</a:t>
-            </a:r>
-          </a:p>
-        </p:txBody>
-      </p:sp>
-      <p:sp>
-        <p:nvSpPr>
-          <p:cNvPr id="3" name="Title 2"/>
-          <p:cNvSpPr>
-            <a:spLocks noGrp="1"/>
-          </p:cNvSpPr>
-          <p:nvPr>
-            <p:ph type="title" idx="2"/>
-          </p:nvPr>
-        </p:nvSpPr>
-        <p:spPr>
-          <a:xfrm>
-            <a:off x="75895" y="0"/>
-            <a:ext cx="8115300" cy="480060"/>
-          </a:xfrm>
-        </p:spPr>
-        <p:txBody>
-          <a:bodyPr wrap="square" lIns="0" rIns="0" tIns="0" bIns="0" anchor="ctr">
-            <a:noAutofit/>
-          </a:bodyPr>
-          <a:lstStyle/>
-          <a:p>
-            <a:pPr algn="l">
-              <a:lnSpc>
-                <a:spcPct val="110000"/>
-              </a:lnSpc>
-              <a:buNone/>
-              <a:defRPr sz="1400" b="0">
-                <a:solidFill>
-                  <a:srgbClr val="303437"/>
-                </a:solidFill>
-                <a:latin typeface="Noto Sans"/>
-              </a:defRPr>
-            </a:pPr>
-            <a:r>
-              <a:rPr sz="1400" b="1" lang="ja-JP" altLang="en-US">
-                <a:solidFill>
-                  <a:srgbClr val="FFFEF8"/>
-                </a:solidFill>
-                <a:latin typeface="Noto Sans"/>
-                <a:ea typeface="Noto Sans CJK JP"/>
-                <a:cs typeface="Noto Sans"/>
-              </a:rPr>
-              <a:t>Appendix: 3. 参考文献</a:t>
-            </a:r>
-          </a:p>
-        </p:txBody>
-      </p:sp>
-      <p:sp>
-        <p:nvSpPr>
-          <p:cNvPr id="4" name="文献 1: CLEVA: Chinese Language Models EVAluation Platform"/>
-          <p:cNvSpPr txBox="1"/>
-          <p:nvPr/>
-        </p:nvSpPr>
-        <p:spPr>
-          <a:xfrm>
-            <a:off x="548640" y="1463040"/>
-            <a:ext cx="8046720" cy="1574419"/>
-          </a:xfrm>
-          <a:prstGeom prst="rect">
-            <a:avLst/>
-          </a:prstGeom>
-          <a:noFill/>
-        </p:spPr>
-        <p:txBody>
-          <a:bodyPr wrap="square" lIns="0" rIns="0" tIns="0" bIns="0">
-            <a:noAutofit/>
-          </a:bodyPr>
-          <a:lstStyle/>
-          <a:p>
-            <a:pPr algn="l">
-              <a:lnSpc>
-                <a:spcPct val="114000"/>
-              </a:lnSpc>
-              <a:spcBef>
-                <a:spcPts val="0"/>
-              </a:spcBef>
-              <a:spcAft>
-                <a:spcPts val="400"/>
-              </a:spcAft>
-              <a:buNone/>
-              <a:defRPr sz="1850" b="0">
-                <a:solidFill>
-                  <a:srgbClr val="303437"/>
-                </a:solidFill>
-                <a:latin typeface="Noto Sans"/>
-              </a:defRPr>
-            </a:pPr>
-            <a:r>
-              <a:rPr sz="1850" b="1" lang="ja-JP" altLang="en-US">
-                <a:solidFill>
-                  <a:srgbClr val="303437"/>
-                </a:solidFill>
-                <a:latin typeface="Noto Sans"/>
-                <a:ea typeface="Noto Sans CJK JP"/>
-                <a:cs typeface="Noto Sans"/>
-              </a:rPr>
-              <a:t>CLEVA: Chinese Language Models EVAluation Platform</a:t>
-            </a:r>
-          </a:p>
-          <a:p>
-            <a:pPr algn="l">
-              <a:lnSpc>
-                <a:spcPct val="114000"/>
-              </a:lnSpc>
-              <a:spcBef>
-                <a:spcPts val="0"/>
-              </a:spcBef>
-              <a:spcAft>
-                <a:spcPts val="500"/>
-              </a:spcAft>
-              <a:buNone/>
-              <a:defRPr sz="1250" b="0">
-                <a:solidFill>
-                  <a:srgbClr val="303437"/>
-                </a:solidFill>
-                <a:latin typeface="Noto Sans"/>
-              </a:defRPr>
-            </a:pPr>
-            <a:r>
-              <a:rPr sz="1250" b="0" lang="ja-JP" altLang="en-US">
-                <a:solidFill>
-                  <a:srgbClr val="626669"/>
-                </a:solidFill>
-                <a:latin typeface="Noto Sans"/>
-                <a:ea typeface="Noto Sans CJK JP"/>
-                <a:cs typeface="Noto Sans"/>
-              </a:rPr>
-              <a:t>Yanyang Li et al. · 2023 · EMNLP: System Demonstrations</a:t>
-            </a:r>
-          </a:p>
-          <a:p>
-            <a:pPr algn="l">
-              <a:lnSpc>
-                <a:spcPct val="114000"/>
-              </a:lnSpc>
-              <a:spcBef>
-                <a:spcPts val="0"/>
-              </a:spcBef>
-              <a:spcAft>
-                <a:spcPts val="400"/>
-              </a:spcAft>
-              <a:buNone/>
-              <a:defRPr sz="1750" b="0">
-                <a:solidFill>
-                  <a:srgbClr val="303437"/>
-                </a:solidFill>
-                <a:latin typeface="Noto Sans"/>
-              </a:defRPr>
-            </a:pPr>
-            <a:r>
-              <a:rPr sz="1750" b="0" lang="ja-JP" altLang="en-US">
-                <a:solidFill>
-                  <a:srgbClr val="303437"/>
-                </a:solidFill>
-                <a:latin typeface="Noto Sans"/>
-                <a:ea typeface="Noto Sans CJK JP"/>
-                <a:cs typeface="Noto Sans"/>
-              </a:rPr>
-              <a:t>中国語モデルを多様な課題で評価するプラットフォーム。短い発話対の言い換え判定に元データを採用する。</a:t>
-            </a:r>
-          </a:p>
-          <a:p>
-            <a:pPr algn="l">
-              <a:lnSpc>
-                <a:spcPct val="114000"/>
-              </a:lnSpc>
-              <a:spcBef>
-                <a:spcPts val="0"/>
-              </a:spcBef>
-              <a:spcAft>
-                <a:spcPts val="0"/>
-              </a:spcAft>
-              <a:buNone/>
-              <a:defRPr sz="1050" b="0">
-                <a:solidFill>
-                  <a:srgbClr val="303437"/>
-                </a:solidFill>
-                <a:latin typeface="Noto Sans"/>
-              </a:defRPr>
-            </a:pPr>
-            <a:r>
-              <a:rPr sz="1050" b="0" lang="ja-JP" altLang="en-US">
-                <a:solidFill>
-                  <a:srgbClr val="626669"/>
-                </a:solidFill>
-                <a:latin typeface="Noto Sans"/>
-                <a:ea typeface="Noto Sans CJK JP"/>
-                <a:cs typeface="Noto Sans"/>
-                <a:hlinkClick r:id="rId2"/>
-              </a:rPr>
-              <a:t>https://aclanthology.org/2023.emnlp-demo.17/</a:t>
-            </a:r>
-          </a:p>
-        </p:txBody>
-      </p:sp>
-      <p:sp>
-        <p:nvSpPr>
-          <p:cNvPr id="5" name="文献 2: CLEVAParaphraseIdentificationScenario / Converter"/>
-          <p:cNvSpPr txBox="1"/>
-          <p:nvPr/>
-        </p:nvSpPr>
-        <p:spPr>
-          <a:xfrm>
-            <a:off x="548640" y="3040507"/>
-            <a:ext cx="8046720" cy="1574419"/>
-          </a:xfrm>
-          <a:prstGeom prst="rect">
-            <a:avLst/>
-          </a:prstGeom>
-          <a:noFill/>
-        </p:spPr>
-        <p:txBody>
-          <a:bodyPr wrap="square" lIns="0" rIns="0" tIns="0" bIns="0">
-            <a:noAutofit/>
-          </a:bodyPr>
-          <a:lstStyle/>
-          <a:p>
-            <a:pPr algn="l">
-              <a:lnSpc>
-                <a:spcPct val="114000"/>
-              </a:lnSpc>
-              <a:spcBef>
-                <a:spcPts val="0"/>
-              </a:spcBef>
-              <a:spcAft>
-                <a:spcPts val="400"/>
-              </a:spcAft>
-              <a:buNone/>
-              <a:defRPr sz="1850" b="0">
-                <a:solidFill>
-                  <a:srgbClr val="303437"/>
-                </a:solidFill>
-                <a:latin typeface="Noto Sans"/>
-              </a:defRPr>
-            </a:pPr>
-            <a:r>
-              <a:rPr sz="1850" b="1" lang="ja-JP" altLang="en-US">
-                <a:solidFill>
-                  <a:srgbClr val="303437"/>
-                </a:solidFill>
-                <a:latin typeface="Noto Sans"/>
-                <a:ea typeface="Noto Sans CJK JP"/>
-                <a:cs typeface="Noto Sans"/>
-              </a:rPr>
-              <a:t>CLEVAParaphraseIdentificationScenario / Converter</a:t>
-            </a:r>
-          </a:p>
-          <a:p>
-            <a:pPr algn="l">
-              <a:lnSpc>
-                <a:spcPct val="114000"/>
-              </a:lnSpc>
-              <a:spcBef>
-                <a:spcPts val="0"/>
-              </a:spcBef>
-              <a:spcAft>
-                <a:spcPts val="500"/>
-              </a:spcAft>
-              <a:buNone/>
-              <a:defRPr sz="1250" b="0">
-                <a:solidFill>
-                  <a:srgbClr val="303437"/>
-                </a:solidFill>
-                <a:latin typeface="Noto Sans"/>
-              </a:defRPr>
-            </a:pPr>
-            <a:r>
-              <a:rPr sz="1250" b="0" lang="ja-JP" altLang="en-US">
-                <a:solidFill>
-                  <a:srgbClr val="626669"/>
-                </a:solidFill>
-                <a:latin typeface="Noto Sans"/>
-                <a:ea typeface="Noto Sans CJK JP"/>
-                <a:cs typeface="Noto Sans"/>
-              </a:rPr>
-              <a:t>Stanford CRFM · HELM v0.4.0 · Python実装</a:t>
-            </a:r>
-          </a:p>
-          <a:p>
-            <a:pPr algn="l">
-              <a:lnSpc>
-                <a:spcPct val="114000"/>
-              </a:lnSpc>
-              <a:spcBef>
-                <a:spcPts val="0"/>
-              </a:spcBef>
-              <a:spcAft>
-                <a:spcPts val="400"/>
-              </a:spcAft>
-              <a:buNone/>
-              <a:defRPr sz="1750" b="0">
-                <a:solidFill>
-                  <a:srgbClr val="303437"/>
-                </a:solidFill>
-                <a:latin typeface="Noto Sans"/>
-              </a:defRPr>
-            </a:pPr>
-            <a:r>
-              <a:rPr sz="1750" b="0" lang="ja-JP" altLang="en-US">
-                <a:solidFill>
-                  <a:srgbClr val="303437"/>
-                </a:solidFill>
-                <a:latin typeface="Noto Sans"/>
-                <a:ea typeface="Noto Sans CJK JP"/>
-                <a:cs typeface="Noto Sans"/>
-              </a:rPr>
-              <a:t>二つの発話を二択形式へ変換する課題。外部データ・テンプレートの読込と、正解参照の変換を実装する。</a:t>
-            </a:r>
-          </a:p>
-          <a:p>
-            <a:pPr algn="l">
-              <a:lnSpc>
-                <a:spcPct val="114000"/>
-              </a:lnSpc>
-              <a:spcBef>
-                <a:spcPts val="0"/>
-              </a:spcBef>
-              <a:spcAft>
-                <a:spcPts val="0"/>
-              </a:spcAft>
-              <a:buNone/>
-              <a:defRPr sz="1050" b="0">
-                <a:solidFill>
-                  <a:srgbClr val="303437"/>
-                </a:solidFill>
-                <a:latin typeface="Noto Sans"/>
-              </a:defRPr>
-            </a:pPr>
-            <a:r>
-              <a:rPr sz="1050" b="0" lang="ja-JP" altLang="en-US">
-                <a:solidFill>
-                  <a:srgbClr val="626669"/>
-                </a:solidFill>
-                <a:latin typeface="Noto Sans"/>
-                <a:ea typeface="Noto Sans CJK JP"/>
-                <a:cs typeface="Noto Sans"/>
-                <a:hlinkClick r:id="rId3"/>
-              </a:rPr>
-              <a:t>https://github.com/stanford-crfm/helm/blob/v0.4.0/src/helm/benchmark/scenarios/cleva_scenario.py</a:t>
-            </a:r>
-          </a:p>
-        </p:txBody>
-      </p:sp>
-    </p:spTree>
-  </p:cSld>
-  <p:clrMapOvr>
-    <a:masterClrMapping/>
-  </p:clrMapOvr>
-</p:sld>
-</file>
-
-<file path=ppt/slides/slide54.xml><?xml version="1.0" encoding="utf-8"?>
-<p:sld xmlns:a="http://schemas.openxmlformats.org/drawingml/2006/main" xmlns:p="http://schemas.openxmlformats.org/presentationml/2006/main" xmlns:r="http://schemas.openxmlformats.org/officeDocument/2006/relationships">
-  <p:cSld>
-    <p:spTree>
-      <p:nvGrpSpPr>
-        <p:cNvPr id="1" name=""/>
-        <p:cNvGrpSpPr/>
-        <p:nvPr/>
-      </p:nvGrpSpPr>
-      <p:grpSpPr/>
-      <p:sp>
-        <p:nvSpPr>
-          <p:cNvPr id="2" name="Title 1"/>
-          <p:cNvSpPr>
-            <a:spLocks noGrp="1"/>
-          </p:cNvSpPr>
-          <p:nvPr>
-            <p:ph type="title"/>
-          </p:nvPr>
-        </p:nvSpPr>
-        <p:spPr>
-          <a:xfrm>
-            <a:off x="468172" y="650138"/>
-            <a:ext cx="8206740" cy="616305"/>
-          </a:xfrm>
-        </p:spPr>
-        <p:txBody>
-          <a:bodyPr wrap="square" lIns="0" rIns="0" tIns="0" bIns="0">
-            <a:noAutofit/>
-          </a:bodyPr>
-          <a:lstStyle/>
-          <a:p>
-            <a:pPr algn="l">
-              <a:lnSpc>
-                <a:spcPct val="110000"/>
-              </a:lnSpc>
-              <a:buNone/>
-              <a:defRPr sz="2800" b="0">
-                <a:solidFill>
-                  <a:srgbClr val="303437"/>
-                </a:solidFill>
-                <a:latin typeface="Noto Sans"/>
-              </a:defRPr>
-            </a:pPr>
-            <a:r>
-              <a:rPr sz="2800" b="1" lang="ja-JP" altLang="en-US">
-                <a:solidFill>
-                  <a:srgbClr val="303437"/>
-                </a:solidFill>
-                <a:latin typeface="Noto Sans"/>
-                <a:ea typeface="Noto Sans CJK JP"/>
-                <a:cs typeface="Noto Sans"/>
-              </a:rPr>
-              <a:t>参考文献</a:t>
-            </a:r>
-          </a:p>
-        </p:txBody>
-      </p:sp>
-      <p:sp>
-        <p:nvSpPr>
-          <p:cNvPr id="3" name="Title 2"/>
-          <p:cNvSpPr>
-            <a:spLocks noGrp="1"/>
-          </p:cNvSpPr>
-          <p:nvPr>
-            <p:ph type="title" idx="2"/>
-          </p:nvPr>
-        </p:nvSpPr>
-        <p:spPr>
-          <a:xfrm>
-            <a:off x="75895" y="0"/>
-            <a:ext cx="8115300" cy="480060"/>
-          </a:xfrm>
-        </p:spPr>
-        <p:txBody>
-          <a:bodyPr wrap="square" lIns="0" rIns="0" tIns="0" bIns="0" anchor="ctr">
-            <a:noAutofit/>
-          </a:bodyPr>
-          <a:lstStyle/>
-          <a:p>
-            <a:pPr algn="l">
-              <a:lnSpc>
-                <a:spcPct val="110000"/>
-              </a:lnSpc>
-              <a:buNone/>
-              <a:defRPr sz="1400" b="0">
-                <a:solidFill>
-                  <a:srgbClr val="303437"/>
-                </a:solidFill>
-                <a:latin typeface="Noto Sans"/>
-              </a:defRPr>
-            </a:pPr>
-            <a:r>
-              <a:rPr sz="1400" b="1" lang="ja-JP" altLang="en-US">
-                <a:solidFill>
-                  <a:srgbClr val="FFFEF8"/>
-                </a:solidFill>
-                <a:latin typeface="Noto Sans"/>
-                <a:ea typeface="Noto Sans CJK JP"/>
-                <a:cs typeface="Noto Sans"/>
-              </a:rPr>
-              <a:t>Appendix: 3. 参考文献</a:t>
-            </a:r>
-          </a:p>
-        </p:txBody>
-      </p:sp>
-      <p:sp>
-        <p:nvSpPr>
-          <p:cNvPr id="4" name="文献 1: pet_bustm.py"/>
-          <p:cNvSpPr txBox="1"/>
-          <p:nvPr/>
-        </p:nvSpPr>
-        <p:spPr>
-          <a:xfrm>
-            <a:off x="548640" y="1463040"/>
-            <a:ext cx="8046720" cy="1574419"/>
-          </a:xfrm>
-          <a:prstGeom prst="rect">
-            <a:avLst/>
-          </a:prstGeom>
-          <a:noFill/>
-        </p:spPr>
-        <p:txBody>
-          <a:bodyPr wrap="square" lIns="0" rIns="0" tIns="0" bIns="0">
-            <a:noAutofit/>
-          </a:bodyPr>
-          <a:lstStyle/>
-          <a:p>
-            <a:pPr algn="l">
-              <a:lnSpc>
-                <a:spcPct val="114000"/>
-              </a:lnSpc>
-              <a:spcBef>
-                <a:spcPts val="0"/>
-              </a:spcBef>
-              <a:spcAft>
-                <a:spcPts val="400"/>
-              </a:spcAft>
-              <a:buNone/>
-              <a:defRPr sz="1850" b="0">
-                <a:solidFill>
-                  <a:srgbClr val="303437"/>
-                </a:solidFill>
-                <a:latin typeface="Noto Sans"/>
-              </a:defRPr>
-            </a:pPr>
-            <a:r>
-              <a:rPr sz="1850" b="1" lang="ja-JP" altLang="en-US">
-                <a:solidFill>
-                  <a:srgbClr val="303437"/>
-                </a:solidFill>
-                <a:latin typeface="Noto Sans"/>
-                <a:ea typeface="Noto Sans CJK JP"/>
-                <a:cs typeface="Noto Sans"/>
-              </a:rPr>
-              <a:t>pet_bustm.py</a:t>
-            </a:r>
-          </a:p>
-          <a:p>
-            <a:pPr algn="l">
-              <a:lnSpc>
-                <a:spcPct val="114000"/>
-              </a:lnSpc>
-              <a:spcBef>
-                <a:spcPts val="0"/>
-              </a:spcBef>
-              <a:spcAft>
-                <a:spcPts val="500"/>
-              </a:spcAft>
-              <a:buNone/>
-              <a:defRPr sz="1250" b="0">
-                <a:solidFill>
-                  <a:srgbClr val="303437"/>
-                </a:solidFill>
-                <a:latin typeface="Noto Sans"/>
-              </a:defRPr>
-            </a:pPr>
-            <a:r>
-              <a:rPr sz="1250" b="0" lang="ja-JP" altLang="en-US">
-                <a:solidFill>
-                  <a:srgbClr val="626669"/>
-                </a:solidFill>
-                <a:latin typeface="Noto Sans"/>
-                <a:ea typeface="Noto Sans CJK JP"/>
-                <a:cs typeface="Noto Sans"/>
-              </a:rPr>
-              <a:t>CLUE team · FewCLUE公式実装</a:t>
-            </a:r>
-          </a:p>
-          <a:p>
-            <a:pPr algn="l">
-              <a:lnSpc>
-                <a:spcPct val="114000"/>
-              </a:lnSpc>
-              <a:spcBef>
-                <a:spcPts val="0"/>
-              </a:spcBef>
-              <a:spcAft>
-                <a:spcPts val="400"/>
-              </a:spcAft>
-              <a:buNone/>
-              <a:defRPr sz="1750" b="0">
-                <a:solidFill>
-                  <a:srgbClr val="303437"/>
-                </a:solidFill>
-                <a:latin typeface="Noto Sans"/>
-              </a:defRPr>
-            </a:pPr>
-            <a:r>
-              <a:rPr sz="1750" b="0" lang="ja-JP" altLang="en-US">
-                <a:solidFill>
-                  <a:srgbClr val="303437"/>
-                </a:solidFill>
-                <a:latin typeface="Noto Sans"/>
-                <a:ea typeface="Noto Sans CJK JP"/>
-                <a:cs typeface="Noto Sans"/>
-              </a:rPr>
-              <a:t>発話対を穴埋め文に変え、「相」「不」のラベル語を予測する。学習・開発・公開テストの読込と採点を実装する。</a:t>
-            </a:r>
-          </a:p>
-          <a:p>
-            <a:pPr algn="l">
-              <a:lnSpc>
-                <a:spcPct val="114000"/>
-              </a:lnSpc>
-              <a:spcBef>
-                <a:spcPts val="0"/>
-              </a:spcBef>
-              <a:spcAft>
-                <a:spcPts val="0"/>
-              </a:spcAft>
-              <a:buNone/>
-              <a:defRPr sz="1050" b="0">
-                <a:solidFill>
-                  <a:srgbClr val="303437"/>
-                </a:solidFill>
-                <a:latin typeface="Noto Sans"/>
-              </a:defRPr>
-            </a:pPr>
-            <a:r>
-              <a:rPr sz="1050" b="0" lang="ja-JP" altLang="en-US">
-                <a:solidFill>
-                  <a:srgbClr val="626669"/>
-                </a:solidFill>
-                <a:latin typeface="Noto Sans"/>
-                <a:ea typeface="Noto Sans CJK JP"/>
-                <a:cs typeface="Noto Sans"/>
-                <a:hlinkClick r:id="rId2"/>
-              </a:rPr>
-              <a:t>https://github.com/CLUEbenchmark/FewCLUE/blob/main/baselines/models_keras/pet/pet_bustm.py</a:t>
             </a:r>
           </a:p>
         </p:txBody>

</xml_diff>